<commit_message>
Ajustes da apresentação e melhorias das tools
</commit_message>
<xml_diff>
--- a/docs/Apresentação.pptx
+++ b/docs/Apresentação.pptx
@@ -21,9 +21,11 @@
     <p:sldId id="271" r:id="rId15"/>
     <p:sldId id="274" r:id="rId16"/>
     <p:sldId id="266" r:id="rId17"/>
-    <p:sldId id="267" r:id="rId18"/>
-    <p:sldId id="268" r:id="rId19"/>
-    <p:sldId id="269" r:id="rId20"/>
+    <p:sldId id="275" r:id="rId18"/>
+    <p:sldId id="276" r:id="rId19"/>
+    <p:sldId id="267" r:id="rId20"/>
+    <p:sldId id="268" r:id="rId21"/>
+    <p:sldId id="269" r:id="rId22"/>
   </p:sldIdLst>
   <p:sldSz cx="12192000" cy="6858000"/>
   <p:notesSz cx="12192000" cy="6858000"/>
@@ -2739,6 +2741,16 @@
               </a:spcBef>
             </a:pPr>
             <a:r>
+              <a:rPr sz="1400" b="1" dirty="0">
+                <a:solidFill>
+                  <a:schemeClr val="bg1"/>
+                </a:solidFill>
+                <a:latin typeface="Calibri"/>
+                <a:cs typeface="Calibri"/>
+              </a:rPr>
+              <a:t>Grupo</a:t>
+            </a:r>
+            <a:r>
               <a:rPr sz="1400" dirty="0">
                 <a:solidFill>
                   <a:schemeClr val="bg1"/>
@@ -2746,7 +2758,7 @@
                 <a:latin typeface="Calibri"/>
                 <a:cs typeface="Calibri"/>
               </a:rPr>
-              <a:t>Grupo:</a:t>
+              <a:t>:</a:t>
             </a:r>
             <a:r>
               <a:rPr lang="pt-BR" sz="1400" dirty="0">
@@ -2763,82 +2775,46 @@
                 <a:solidFill>
                   <a:schemeClr val="bg1"/>
                 </a:solidFill>
-              </a:rPr>
-              <a:t>André Barbosa Alves dos Santos</a:t>
+                <a:latin typeface="+mj-lt"/>
+              </a:rPr>
+              <a:t>Rafael Marques Mansano</a:t>
+            </a:r>
+            <a:r>
+              <a:rPr sz="1400" spc="-10" dirty="0">
+                <a:solidFill>
+                  <a:schemeClr val="bg1"/>
+                </a:solidFill>
+                <a:latin typeface="+mj-lt"/>
+                <a:cs typeface="Calibri"/>
+              </a:rPr>
+              <a:t> </a:t>
+            </a:r>
+            <a:r>
+              <a:rPr sz="1400" dirty="0">
+                <a:solidFill>
+                  <a:schemeClr val="bg1"/>
+                </a:solidFill>
+                <a:latin typeface="+mj-lt"/>
+                <a:cs typeface="Calibri"/>
+              </a:rPr>
+              <a:t>|</a:t>
             </a:r>
             <a:r>
               <a:rPr sz="1400" spc="-15" dirty="0">
                 <a:solidFill>
                   <a:schemeClr val="bg1"/>
                 </a:solidFill>
-                <a:latin typeface="Calibri"/>
-                <a:cs typeface="Calibri"/>
-              </a:rPr>
-              <a:t> </a:t>
-            </a:r>
-            <a:r>
-              <a:rPr sz="1400" dirty="0">
+                <a:latin typeface="+mj-lt"/>
+                <a:cs typeface="Calibri"/>
+              </a:rPr>
+              <a:t> </a:t>
+            </a:r>
+            <a:r>
+              <a:rPr lang="pt-BR" sz="1400" dirty="0">
                 <a:solidFill>
                   <a:schemeClr val="bg1"/>
                 </a:solidFill>
-                <a:latin typeface="Calibri"/>
-                <a:cs typeface="Calibri"/>
-              </a:rPr>
-              <a:t>|</a:t>
-            </a:r>
-            <a:r>
-              <a:rPr lang="pt-BR" sz="1400" dirty="0">
-                <a:solidFill>
-                  <a:schemeClr val="bg1"/>
-                </a:solidFill>
-                <a:latin typeface="Calibri"/>
-                <a:cs typeface="Calibri"/>
-              </a:rPr>
-              <a:t> </a:t>
-            </a:r>
-            <a:r>
-              <a:rPr lang="pt-BR" sz="1400" dirty="0">
-                <a:solidFill>
-                  <a:schemeClr val="bg1"/>
-                </a:solidFill>
-              </a:rPr>
-              <a:t>Rafael Marques Mansano</a:t>
-            </a:r>
-            <a:r>
-              <a:rPr sz="1400" spc="-10" dirty="0">
-                <a:solidFill>
-                  <a:schemeClr val="bg1"/>
-                </a:solidFill>
-                <a:latin typeface="Calibri"/>
-                <a:cs typeface="Calibri"/>
-              </a:rPr>
-              <a:t> </a:t>
-            </a:r>
-            <a:r>
-              <a:rPr sz="1400" dirty="0">
-                <a:solidFill>
-                  <a:schemeClr val="bg1"/>
-                </a:solidFill>
-                <a:latin typeface="Calibri"/>
-                <a:cs typeface="Calibri"/>
-              </a:rPr>
-              <a:t>|</a:t>
-            </a:r>
-            <a:r>
-              <a:rPr sz="1400" spc="-15" dirty="0">
-                <a:solidFill>
-                  <a:schemeClr val="bg1"/>
-                </a:solidFill>
-                <a:latin typeface="Calibri"/>
-                <a:cs typeface="Calibri"/>
-              </a:rPr>
-              <a:t> </a:t>
-            </a:r>
-            <a:r>
-              <a:rPr lang="pt-BR" sz="1400" dirty="0">
-                <a:solidFill>
-                  <a:schemeClr val="bg1"/>
-                </a:solidFill>
+                <a:latin typeface="+mj-lt"/>
               </a:rPr>
               <a:t>Vinicius de Oliveira Silva</a:t>
             </a:r>
@@ -4451,6 +4427,10 @@
           </p:nvPr>
         </p:nvSpPr>
         <p:spPr>
+          <a:xfrm>
+            <a:off x="11275097" y="6507344"/>
+            <a:ext cx="351790" cy="145553"/>
+          </a:xfrm>
           <a:prstGeom prst="rect">
             <a:avLst/>
           </a:prstGeom>
@@ -4486,9 +4466,10 @@
               <a:t> </a:t>
             </a:r>
             <a:r>
-              <a:rPr spc="-25" dirty="0"/>
-              <a:t>14</a:t>
-            </a:r>
+              <a:rPr lang="pt-BR" spc="-25" dirty="0"/>
+              <a:t>18</a:t>
+            </a:r>
+            <a:endParaRPr spc="-25" dirty="0"/>
           </a:p>
         </p:txBody>
       </p:sp>
@@ -5646,6 +5627,10 @@
           </p:nvPr>
         </p:nvSpPr>
         <p:spPr>
+          <a:xfrm>
+            <a:off x="11275097" y="6507344"/>
+            <a:ext cx="351790" cy="145553"/>
+          </a:xfrm>
           <a:prstGeom prst="rect">
             <a:avLst/>
           </a:prstGeom>
@@ -5681,9 +5666,10 @@
               <a:t> </a:t>
             </a:r>
             <a:r>
-              <a:rPr spc="-25" dirty="0"/>
-              <a:t>14</a:t>
-            </a:r>
+              <a:rPr lang="pt-BR" spc="-25" dirty="0"/>
+              <a:t>18</a:t>
+            </a:r>
+            <a:endParaRPr spc="-25" dirty="0"/>
           </a:p>
         </p:txBody>
       </p:sp>
@@ -6298,7 +6284,7 @@
                 <a:latin typeface="Calibri"/>
                 <a:cs typeface="Calibri"/>
               </a:rPr>
-              <a:t>0,028</a:t>
+              <a:t>0,036953</a:t>
             </a:r>
             <a:r>
               <a:rPr sz="1200" b="1" i="1" spc="-10" dirty="0">
@@ -6378,7 +6364,7 @@
               <a:t> </a:t>
             </a:r>
             <a:r>
-              <a:rPr sz="1200" b="1" i="1" dirty="0">
+              <a:rPr sz="1200" b="1" i="1" dirty="0" err="1">
                 <a:solidFill>
                   <a:srgbClr val="191919"/>
                 </a:solidFill>
@@ -6462,7 +6448,7 @@
                 <a:latin typeface="Calibri"/>
                 <a:cs typeface="Calibri"/>
               </a:rPr>
-              <a:t>69</a:t>
+              <a:t>1232</a:t>
             </a:r>
             <a:r>
               <a:rPr sz="1200" b="1" i="1" spc="-10" dirty="0">
@@ -8193,6 +8179,10 @@
           </p:nvPr>
         </p:nvSpPr>
         <p:spPr>
+          <a:xfrm>
+            <a:off x="11275097" y="6507344"/>
+            <a:ext cx="351790" cy="145553"/>
+          </a:xfrm>
           <a:prstGeom prst="rect">
             <a:avLst/>
           </a:prstGeom>
@@ -8228,9 +8218,10 @@
               <a:t> </a:t>
             </a:r>
             <a:r>
-              <a:rPr spc="-25" dirty="0"/>
-              <a:t>14</a:t>
-            </a:r>
+              <a:rPr lang="pt-BR" spc="-25" dirty="0"/>
+              <a:t>18</a:t>
+            </a:r>
+            <a:endParaRPr spc="-25" dirty="0"/>
           </a:p>
         </p:txBody>
       </p:sp>
@@ -8243,6 +8234,275 @@
 </file>
 
 <file path=ppt/slides/slide17.xml><?xml version="1.0" encoding="utf-8"?>
+<p:sld xmlns:a="http://schemas.openxmlformats.org/drawingml/2006/main" xmlns:r="http://schemas.openxmlformats.org/officeDocument/2006/relationships" xmlns:p="http://schemas.openxmlformats.org/presentationml/2006/main">
+  <p:cSld>
+    <p:spTree>
+      <p:nvGrpSpPr>
+        <p:cNvPr id="1" name=""/>
+        <p:cNvGrpSpPr/>
+        <p:nvPr/>
+      </p:nvGrpSpPr>
+      <p:grpSpPr>
+        <a:xfrm>
+          <a:off x="0" y="0"/>
+          <a:ext cx="0" cy="0"/>
+          <a:chOff x="0" y="0"/>
+          <a:chExt cx="0" cy="0"/>
+        </a:xfrm>
+      </p:grpSpPr>
+      <p:sp>
+        <p:nvSpPr>
+          <p:cNvPr id="2" name="Título 1">
+            <a:extLst>
+              <a:ext uri="{FF2B5EF4-FFF2-40B4-BE49-F238E27FC236}">
+                <a16:creationId xmlns:a16="http://schemas.microsoft.com/office/drawing/2014/main" id="{49DAB00E-1657-E080-D372-8FDE0EE8CF88}"/>
+              </a:ext>
+            </a:extLst>
+          </p:cNvPr>
+          <p:cNvSpPr>
+            <a:spLocks noGrp="1"/>
+          </p:cNvSpPr>
+          <p:nvPr>
+            <p:ph type="title"/>
+          </p:nvPr>
+        </p:nvSpPr>
+        <p:spPr>
+          <a:xfrm>
+            <a:off x="444144" y="200418"/>
+            <a:ext cx="5201920" cy="400110"/>
+          </a:xfrm>
+        </p:spPr>
+        <p:txBody>
+          <a:bodyPr/>
+          <a:lstStyle/>
+          <a:p>
+            <a:r>
+              <a:rPr lang="pt-BR" dirty="0"/>
+              <a:t>Custo Total</a:t>
+            </a:r>
+          </a:p>
+        </p:txBody>
+      </p:sp>
+      <p:sp>
+        <p:nvSpPr>
+          <p:cNvPr id="3" name="Espaço Reservado para Texto 2">
+            <a:extLst>
+              <a:ext uri="{FF2B5EF4-FFF2-40B4-BE49-F238E27FC236}">
+                <a16:creationId xmlns:a16="http://schemas.microsoft.com/office/drawing/2014/main" id="{D8453E08-5727-87DB-81F6-D6093AE1E943}"/>
+              </a:ext>
+            </a:extLst>
+          </p:cNvPr>
+          <p:cNvSpPr>
+            <a:spLocks noGrp="1"/>
+          </p:cNvSpPr>
+          <p:nvPr>
+            <p:ph type="body" idx="1"/>
+          </p:nvPr>
+        </p:nvSpPr>
+        <p:spPr>
+          <a:xfrm>
+            <a:off x="416241" y="1094421"/>
+            <a:ext cx="11329035" cy="276999"/>
+          </a:xfrm>
+        </p:spPr>
+        <p:txBody>
+          <a:bodyPr/>
+          <a:lstStyle/>
+          <a:p>
+            <a:r>
+              <a:rPr lang="pt-BR" dirty="0"/>
+              <a:t>Total gasto entre 04/06/2026 e 09/06/2026</a:t>
+            </a:r>
+          </a:p>
+        </p:txBody>
+      </p:sp>
+      <p:pic>
+        <p:nvPicPr>
+          <p:cNvPr id="5" name="Imagem 4">
+            <a:extLst>
+              <a:ext uri="{FF2B5EF4-FFF2-40B4-BE49-F238E27FC236}">
+                <a16:creationId xmlns:a16="http://schemas.microsoft.com/office/drawing/2014/main" id="{C161A19E-14A3-792D-74BD-00DDB76B2089}"/>
+              </a:ext>
+            </a:extLst>
+          </p:cNvPr>
+          <p:cNvPicPr>
+            <a:picLocks noChangeAspect="1"/>
+          </p:cNvPicPr>
+          <p:nvPr/>
+        </p:nvPicPr>
+        <p:blipFill>
+          <a:blip r:embed="rId2"/>
+          <a:stretch>
+            <a:fillRect/>
+          </a:stretch>
+        </p:blipFill>
+        <p:spPr>
+          <a:xfrm>
+            <a:off x="1451606" y="1524000"/>
+            <a:ext cx="9288787" cy="4877155"/>
+          </a:xfrm>
+          <a:prstGeom prst="rect">
+            <a:avLst/>
+          </a:prstGeom>
+        </p:spPr>
+      </p:pic>
+    </p:spTree>
+    <p:extLst>
+      <p:ext uri="{BB962C8B-B14F-4D97-AF65-F5344CB8AC3E}">
+        <p14:creationId xmlns:p14="http://schemas.microsoft.com/office/powerpoint/2010/main" val="2428703534"/>
+      </p:ext>
+    </p:extLst>
+  </p:cSld>
+  <p:clrMapOvr>
+    <a:masterClrMapping/>
+  </p:clrMapOvr>
+</p:sld>
+</file>
+
+<file path=ppt/slides/slide18.xml><?xml version="1.0" encoding="utf-8"?>
+<p:sld xmlns:a="http://schemas.openxmlformats.org/drawingml/2006/main" xmlns:r="http://schemas.openxmlformats.org/officeDocument/2006/relationships" xmlns:p="http://schemas.openxmlformats.org/presentationml/2006/main">
+  <p:cSld>
+    <p:spTree>
+      <p:nvGrpSpPr>
+        <p:cNvPr id="1" name=""/>
+        <p:cNvGrpSpPr/>
+        <p:nvPr/>
+      </p:nvGrpSpPr>
+      <p:grpSpPr>
+        <a:xfrm>
+          <a:off x="0" y="0"/>
+          <a:ext cx="0" cy="0"/>
+          <a:chOff x="0" y="0"/>
+          <a:chExt cx="0" cy="0"/>
+        </a:xfrm>
+      </p:grpSpPr>
+      <p:sp>
+        <p:nvSpPr>
+          <p:cNvPr id="2" name="Título 1">
+            <a:extLst>
+              <a:ext uri="{FF2B5EF4-FFF2-40B4-BE49-F238E27FC236}">
+                <a16:creationId xmlns:a16="http://schemas.microsoft.com/office/drawing/2014/main" id="{D0D17165-E37E-18F7-807F-FA9B336238BF}"/>
+              </a:ext>
+            </a:extLst>
+          </p:cNvPr>
+          <p:cNvSpPr>
+            <a:spLocks noGrp="1"/>
+          </p:cNvSpPr>
+          <p:nvPr>
+            <p:ph type="title"/>
+          </p:nvPr>
+        </p:nvSpPr>
+        <p:spPr>
+          <a:xfrm>
+            <a:off x="444144" y="200418"/>
+            <a:ext cx="10681056" cy="1200329"/>
+          </a:xfrm>
+        </p:spPr>
+        <p:txBody>
+          <a:bodyPr/>
+          <a:lstStyle/>
+          <a:p>
+            <a:r>
+              <a:rPr lang="pt-BR" dirty="0"/>
+              <a:t>Por que o custo estimado não bate exatamente com o painel da </a:t>
+            </a:r>
+            <a:r>
+              <a:rPr lang="pt-BR" dirty="0" err="1"/>
+              <a:t>DeepSeek</a:t>
+            </a:r>
+            <a:r>
+              <a:rPr lang="pt-BR" dirty="0"/>
+              <a:t>?</a:t>
+            </a:r>
+          </a:p>
+        </p:txBody>
+      </p:sp>
+      <p:sp>
+        <p:nvSpPr>
+          <p:cNvPr id="3" name="Espaço Reservado para Texto 2">
+            <a:extLst>
+              <a:ext uri="{FF2B5EF4-FFF2-40B4-BE49-F238E27FC236}">
+                <a16:creationId xmlns:a16="http://schemas.microsoft.com/office/drawing/2014/main" id="{0146ECD0-3A18-ABAD-0E98-3EFA205425A2}"/>
+              </a:ext>
+            </a:extLst>
+          </p:cNvPr>
+          <p:cNvSpPr>
+            <a:spLocks noGrp="1"/>
+          </p:cNvSpPr>
+          <p:nvPr>
+            <p:ph type="body" idx="1"/>
+          </p:nvPr>
+        </p:nvSpPr>
+        <p:spPr>
+          <a:xfrm>
+            <a:off x="444144" y="1295400"/>
+            <a:ext cx="11329035" cy="1107996"/>
+          </a:xfrm>
+        </p:spPr>
+        <p:txBody>
+          <a:bodyPr/>
+          <a:lstStyle/>
+          <a:p>
+            <a:pPr algn="just"/>
+            <a:r>
+              <a:rPr lang="pt-BR" dirty="0"/>
+              <a:t>O sistema estima o custo a partir da quantidade de tokens processados e dos preços públicos do modelo. Entretanto, o valor efetivamente cobrado pela </a:t>
+            </a:r>
+            <a:r>
+              <a:rPr lang="pt-BR" dirty="0" err="1"/>
+              <a:t>DeepSeek</a:t>
+            </a:r>
+            <a:r>
+              <a:rPr lang="pt-BR" dirty="0"/>
+              <a:t> pode ser menor devido a mecanismos de cache de contexto (cache hit), reutilização de partes do prompt e políticas internas de cobrança. Por isso o custo apresentado pelo projeto deve ser interpretado como uma estimativa.</a:t>
+            </a:r>
+          </a:p>
+        </p:txBody>
+      </p:sp>
+      <p:pic>
+        <p:nvPicPr>
+          <p:cNvPr id="5" name="Imagem 4">
+            <a:extLst>
+              <a:ext uri="{FF2B5EF4-FFF2-40B4-BE49-F238E27FC236}">
+                <a16:creationId xmlns:a16="http://schemas.microsoft.com/office/drawing/2014/main" id="{8881F2A3-8D7F-50A4-B22E-335396AF8485}"/>
+              </a:ext>
+            </a:extLst>
+          </p:cNvPr>
+          <p:cNvPicPr>
+            <a:picLocks noChangeAspect="1"/>
+          </p:cNvPicPr>
+          <p:nvPr/>
+        </p:nvPicPr>
+        <p:blipFill>
+          <a:blip r:embed="rId2"/>
+          <a:stretch>
+            <a:fillRect/>
+          </a:stretch>
+        </p:blipFill>
+        <p:spPr>
+          <a:xfrm>
+            <a:off x="3051591" y="2375964"/>
+            <a:ext cx="6088818" cy="4426032"/>
+          </a:xfrm>
+          <a:prstGeom prst="rect">
+            <a:avLst/>
+          </a:prstGeom>
+        </p:spPr>
+      </p:pic>
+    </p:spTree>
+    <p:extLst>
+      <p:ext uri="{BB962C8B-B14F-4D97-AF65-F5344CB8AC3E}">
+        <p14:creationId xmlns:p14="http://schemas.microsoft.com/office/powerpoint/2010/main" val="3019731060"/>
+      </p:ext>
+    </p:extLst>
+  </p:cSld>
+  <p:clrMapOvr>
+    <a:masterClrMapping/>
+  </p:clrMapOvr>
+</p:sld>
+</file>
+
+<file path=ppt/slides/slide19.xml><?xml version="1.0" encoding="utf-8"?>
 <p:sld xmlns:a="http://schemas.openxmlformats.org/drawingml/2006/main" xmlns:r="http://schemas.openxmlformats.org/officeDocument/2006/relationships" xmlns:p="http://schemas.openxmlformats.org/presentationml/2006/main">
   <p:cSld>
     <p:spTree>
@@ -8844,6 +9104,10 @@
           </p:nvPr>
         </p:nvSpPr>
         <p:spPr>
+          <a:xfrm>
+            <a:off x="11275097" y="6507344"/>
+            <a:ext cx="351790" cy="145553"/>
+          </a:xfrm>
           <a:prstGeom prst="rect">
             <a:avLst/>
           </a:prstGeom>
@@ -8864,7 +9128,7 @@
             </a:pPr>
             <a:fld id="{81D60167-4931-47E6-BA6A-407CBD079E47}" type="slidenum">
               <a:rPr dirty="0"/>
-              <a:t>17</a:t>
+              <a:t>19</a:t>
             </a:fld>
             <a:r>
               <a:rPr spc="-15" dirty="0"/>
@@ -8880,8 +9144,13 @@
             </a:r>
             <a:r>
               <a:rPr spc="-25" dirty="0"/>
-              <a:t>14</a:t>
-            </a:r>
+              <a:t>1</a:t>
+            </a:r>
+            <a:r>
+              <a:rPr lang="pt-BR" spc="-25" dirty="0"/>
+              <a:t>8</a:t>
+            </a:r>
+            <a:endParaRPr spc="-25" dirty="0"/>
           </a:p>
         </p:txBody>
       </p:sp>
@@ -8893,7 +9162,7 @@
 </p:sld>
 </file>
 
-<file path=ppt/slides/slide18.xml><?xml version="1.0" encoding="utf-8"?>
+<file path=ppt/slides/slide2.xml><?xml version="1.0" encoding="utf-8"?>
 <p:sld xmlns:a="http://schemas.openxmlformats.org/drawingml/2006/main" xmlns:r="http://schemas.openxmlformats.org/officeDocument/2006/relationships" xmlns:p="http://schemas.openxmlformats.org/presentationml/2006/main">
   <p:cSld>
     <p:spTree>
@@ -8921,10 +9190,6 @@
           </p:nvPr>
         </p:nvSpPr>
         <p:spPr>
-          <a:xfrm>
-            <a:off x="444144" y="200418"/>
-            <a:ext cx="1606550" cy="421640"/>
-          </a:xfrm>
           <a:prstGeom prst="rect">
             <a:avLst/>
           </a:prstGeom>
@@ -8945,7 +9210,7 @@
             </a:pPr>
             <a:r>
               <a:rPr spc="-10" dirty="0"/>
-              <a:t>Referências</a:t>
+              <a:t>Agenda</a:t>
             </a:r>
           </a:p>
         </p:txBody>
@@ -9000,8 +9265,8 @@
         </p:nvSpPr>
         <p:spPr>
           <a:xfrm>
-            <a:off x="381000" y="1676400"/>
-            <a:ext cx="11506200" cy="3775329"/>
+            <a:off x="991336" y="1794788"/>
+            <a:ext cx="2747010" cy="299720"/>
           </a:xfrm>
           <a:prstGeom prst="rect">
             <a:avLst/>
@@ -9013,111 +9278,1453 @@
           </a:bodyPr>
           <a:lstStyle/>
           <a:p>
+            <a:pPr marL="12700">
+              <a:lnSpc>
+                <a:spcPct val="100000"/>
+              </a:lnSpc>
+              <a:spcBef>
+                <a:spcPts val="100"/>
+              </a:spcBef>
+            </a:pPr>
+            <a:r>
+              <a:rPr sz="1800" b="1" dirty="0">
+                <a:solidFill>
+                  <a:srgbClr val="003366"/>
+                </a:solidFill>
+                <a:latin typeface="Calibri"/>
+                <a:cs typeface="Calibri"/>
+              </a:rPr>
+              <a:t>1.</a:t>
+            </a:r>
+            <a:r>
+              <a:rPr sz="1800" b="1" spc="-20" dirty="0">
+                <a:solidFill>
+                  <a:srgbClr val="003366"/>
+                </a:solidFill>
+                <a:latin typeface="Calibri"/>
+                <a:cs typeface="Calibri"/>
+              </a:rPr>
+              <a:t> </a:t>
+            </a:r>
+            <a:r>
+              <a:rPr sz="1800" b="1" dirty="0">
+                <a:solidFill>
+                  <a:srgbClr val="003366"/>
+                </a:solidFill>
+                <a:latin typeface="Calibri"/>
+                <a:cs typeface="Calibri"/>
+              </a:rPr>
+              <a:t>O</a:t>
+            </a:r>
+            <a:r>
+              <a:rPr sz="1800" b="1" spc="-15" dirty="0">
+                <a:solidFill>
+                  <a:srgbClr val="003366"/>
+                </a:solidFill>
+                <a:latin typeface="Calibri"/>
+                <a:cs typeface="Calibri"/>
+              </a:rPr>
+              <a:t> </a:t>
+            </a:r>
+            <a:r>
+              <a:rPr sz="1800" b="1" dirty="0">
+                <a:solidFill>
+                  <a:srgbClr val="003366"/>
+                </a:solidFill>
+                <a:latin typeface="Calibri"/>
+                <a:cs typeface="Calibri"/>
+              </a:rPr>
+              <a:t>problema</a:t>
+            </a:r>
+            <a:r>
+              <a:rPr sz="1800" b="1" spc="-15" dirty="0">
+                <a:solidFill>
+                  <a:srgbClr val="003366"/>
+                </a:solidFill>
+                <a:latin typeface="Calibri"/>
+                <a:cs typeface="Calibri"/>
+              </a:rPr>
+              <a:t> </a:t>
+            </a:r>
+            <a:r>
+              <a:rPr sz="1800" b="1" dirty="0">
+                <a:solidFill>
+                  <a:srgbClr val="003366"/>
+                </a:solidFill>
+                <a:latin typeface="Calibri"/>
+                <a:cs typeface="Calibri"/>
+              </a:rPr>
+              <a:t>e</a:t>
+            </a:r>
+            <a:r>
+              <a:rPr sz="1800" b="1" spc="-10" dirty="0">
+                <a:solidFill>
+                  <a:srgbClr val="003366"/>
+                </a:solidFill>
+                <a:latin typeface="Calibri"/>
+                <a:cs typeface="Calibri"/>
+              </a:rPr>
+              <a:t> </a:t>
+            </a:r>
+            <a:r>
+              <a:rPr sz="1800" b="1" dirty="0">
+                <a:solidFill>
+                  <a:srgbClr val="003366"/>
+                </a:solidFill>
+                <a:latin typeface="Calibri"/>
+                <a:cs typeface="Calibri"/>
+              </a:rPr>
+              <a:t>a</a:t>
+            </a:r>
+            <a:r>
+              <a:rPr sz="1800" b="1" spc="-20" dirty="0">
+                <a:solidFill>
+                  <a:srgbClr val="003366"/>
+                </a:solidFill>
+                <a:latin typeface="Calibri"/>
+                <a:cs typeface="Calibri"/>
+              </a:rPr>
+              <a:t> </a:t>
+            </a:r>
+            <a:r>
+              <a:rPr sz="1800" b="1" spc="-10" dirty="0">
+                <a:solidFill>
+                  <a:srgbClr val="003366"/>
+                </a:solidFill>
+                <a:latin typeface="Calibri"/>
+                <a:cs typeface="Calibri"/>
+              </a:rPr>
+              <a:t>motivação</a:t>
+            </a:r>
+            <a:endParaRPr sz="1800" dirty="0">
+              <a:latin typeface="Calibri"/>
+              <a:cs typeface="Calibri"/>
+            </a:endParaRPr>
+          </a:p>
+        </p:txBody>
+      </p:sp>
+      <p:sp>
+        <p:nvSpPr>
+          <p:cNvPr id="5" name="object 5"/>
+          <p:cNvSpPr txBox="1"/>
+          <p:nvPr/>
+        </p:nvSpPr>
+        <p:spPr>
+          <a:xfrm>
+            <a:off x="991336" y="2667774"/>
+            <a:ext cx="2121535" cy="299720"/>
+          </a:xfrm>
+          <a:prstGeom prst="rect">
+            <a:avLst/>
+          </a:prstGeom>
+        </p:spPr>
+        <p:txBody>
+          <a:bodyPr vert="horz" wrap="square" lIns="0" tIns="12700" rIns="0" bIns="0" rtlCol="0">
+            <a:spAutoFit/>
+          </a:bodyPr>
+          <a:lstStyle/>
+          <a:p>
+            <a:pPr marL="12700">
+              <a:lnSpc>
+                <a:spcPct val="100000"/>
+              </a:lnSpc>
+              <a:spcBef>
+                <a:spcPts val="100"/>
+              </a:spcBef>
+            </a:pPr>
+            <a:r>
+              <a:rPr sz="1800" b="1" dirty="0">
+                <a:solidFill>
+                  <a:srgbClr val="003366"/>
+                </a:solidFill>
+                <a:latin typeface="Calibri"/>
+                <a:cs typeface="Calibri"/>
+              </a:rPr>
+              <a:t>2.</a:t>
+            </a:r>
+            <a:r>
+              <a:rPr sz="1800" b="1" spc="-35" dirty="0">
+                <a:solidFill>
+                  <a:srgbClr val="003366"/>
+                </a:solidFill>
+                <a:latin typeface="Calibri"/>
+                <a:cs typeface="Calibri"/>
+              </a:rPr>
+              <a:t> </a:t>
+            </a:r>
+            <a:r>
+              <a:rPr sz="1800" b="1" dirty="0">
+                <a:solidFill>
+                  <a:srgbClr val="003366"/>
+                </a:solidFill>
+                <a:latin typeface="Calibri"/>
+                <a:cs typeface="Calibri"/>
+              </a:rPr>
+              <a:t>O</a:t>
+            </a:r>
+            <a:r>
+              <a:rPr sz="1800" b="1" spc="-30" dirty="0">
+                <a:solidFill>
+                  <a:srgbClr val="003366"/>
+                </a:solidFill>
+                <a:latin typeface="Calibri"/>
+                <a:cs typeface="Calibri"/>
+              </a:rPr>
+              <a:t> </a:t>
+            </a:r>
+            <a:r>
+              <a:rPr sz="1800" b="1" dirty="0">
+                <a:solidFill>
+                  <a:srgbClr val="003366"/>
+                </a:solidFill>
+                <a:latin typeface="Calibri"/>
+                <a:cs typeface="Calibri"/>
+              </a:rPr>
+              <a:t>dataset</a:t>
+            </a:r>
+            <a:r>
+              <a:rPr sz="1800" b="1" spc="-30" dirty="0">
+                <a:solidFill>
+                  <a:srgbClr val="003366"/>
+                </a:solidFill>
+                <a:latin typeface="Calibri"/>
+                <a:cs typeface="Calibri"/>
+              </a:rPr>
+              <a:t> </a:t>
+            </a:r>
+            <a:r>
+              <a:rPr sz="1800" b="1" spc="-10" dirty="0">
+                <a:solidFill>
+                  <a:srgbClr val="003366"/>
+                </a:solidFill>
+                <a:latin typeface="Calibri"/>
+                <a:cs typeface="Calibri"/>
+              </a:rPr>
+              <a:t>escolhido</a:t>
+            </a:r>
+            <a:endParaRPr sz="1800" dirty="0">
+              <a:latin typeface="Calibri"/>
+              <a:cs typeface="Calibri"/>
+            </a:endParaRPr>
+          </a:p>
+        </p:txBody>
+      </p:sp>
+      <p:sp>
+        <p:nvSpPr>
+          <p:cNvPr id="6" name="object 6"/>
+          <p:cNvSpPr txBox="1"/>
+          <p:nvPr/>
+        </p:nvSpPr>
+        <p:spPr>
+          <a:xfrm>
+            <a:off x="994612" y="3540760"/>
+            <a:ext cx="2345690" cy="299720"/>
+          </a:xfrm>
+          <a:prstGeom prst="rect">
+            <a:avLst/>
+          </a:prstGeom>
+        </p:spPr>
+        <p:txBody>
+          <a:bodyPr vert="horz" wrap="square" lIns="0" tIns="12700" rIns="0" bIns="0" rtlCol="0">
+            <a:spAutoFit/>
+          </a:bodyPr>
+          <a:lstStyle/>
+          <a:p>
+            <a:pPr marL="12700">
+              <a:lnSpc>
+                <a:spcPct val="100000"/>
+              </a:lnSpc>
+              <a:spcBef>
+                <a:spcPts val="100"/>
+              </a:spcBef>
+            </a:pPr>
+            <a:r>
+              <a:rPr sz="1800" b="1" dirty="0">
+                <a:solidFill>
+                  <a:srgbClr val="003366"/>
+                </a:solidFill>
+                <a:latin typeface="Calibri"/>
+                <a:cs typeface="Calibri"/>
+              </a:rPr>
+              <a:t>3.</a:t>
+            </a:r>
+            <a:r>
+              <a:rPr sz="1800" b="1" spc="-20" dirty="0">
+                <a:solidFill>
+                  <a:srgbClr val="003366"/>
+                </a:solidFill>
+                <a:latin typeface="Calibri"/>
+                <a:cs typeface="Calibri"/>
+              </a:rPr>
+              <a:t> </a:t>
+            </a:r>
+            <a:r>
+              <a:rPr sz="1800" b="1" spc="-10" dirty="0">
+                <a:solidFill>
+                  <a:srgbClr val="003366"/>
+                </a:solidFill>
+                <a:latin typeface="Calibri"/>
+                <a:cs typeface="Calibri"/>
+              </a:rPr>
+              <a:t>Arquitetura</a:t>
+            </a:r>
+            <a:r>
+              <a:rPr sz="1800" b="1" spc="-15" dirty="0">
+                <a:solidFill>
+                  <a:srgbClr val="003366"/>
+                </a:solidFill>
+                <a:latin typeface="Calibri"/>
+                <a:cs typeface="Calibri"/>
+              </a:rPr>
+              <a:t> </a:t>
+            </a:r>
+            <a:r>
+              <a:rPr sz="1800" b="1" dirty="0">
+                <a:solidFill>
+                  <a:srgbClr val="003366"/>
+                </a:solidFill>
+                <a:latin typeface="Calibri"/>
+                <a:cs typeface="Calibri"/>
+              </a:rPr>
+              <a:t>do</a:t>
+            </a:r>
+            <a:r>
+              <a:rPr sz="1800" b="1" spc="-10" dirty="0">
+                <a:solidFill>
+                  <a:srgbClr val="003366"/>
+                </a:solidFill>
+                <a:latin typeface="Calibri"/>
+                <a:cs typeface="Calibri"/>
+              </a:rPr>
+              <a:t> agente</a:t>
+            </a:r>
+            <a:endParaRPr sz="1800" dirty="0">
+              <a:latin typeface="Calibri"/>
+              <a:cs typeface="Calibri"/>
+            </a:endParaRPr>
+          </a:p>
+        </p:txBody>
+      </p:sp>
+      <p:sp>
+        <p:nvSpPr>
+          <p:cNvPr id="7" name="object 7"/>
+          <p:cNvSpPr txBox="1"/>
+          <p:nvPr/>
+        </p:nvSpPr>
+        <p:spPr>
+          <a:xfrm>
+            <a:off x="991336" y="4415612"/>
+            <a:ext cx="2964815" cy="299720"/>
+          </a:xfrm>
+          <a:prstGeom prst="rect">
+            <a:avLst/>
+          </a:prstGeom>
+        </p:spPr>
+        <p:txBody>
+          <a:bodyPr vert="horz" wrap="square" lIns="0" tIns="12700" rIns="0" bIns="0" rtlCol="0">
+            <a:spAutoFit/>
+          </a:bodyPr>
+          <a:lstStyle/>
+          <a:p>
+            <a:pPr marL="12700">
+              <a:lnSpc>
+                <a:spcPct val="100000"/>
+              </a:lnSpc>
+              <a:spcBef>
+                <a:spcPts val="100"/>
+              </a:spcBef>
+            </a:pPr>
+            <a:r>
+              <a:rPr sz="1800" b="1" dirty="0">
+                <a:solidFill>
+                  <a:srgbClr val="003366"/>
+                </a:solidFill>
+                <a:latin typeface="Calibri"/>
+                <a:cs typeface="Calibri"/>
+              </a:rPr>
+              <a:t>4.</a:t>
+            </a:r>
+            <a:r>
+              <a:rPr sz="1800" b="1" spc="-35" dirty="0">
+                <a:solidFill>
+                  <a:srgbClr val="003366"/>
+                </a:solidFill>
+                <a:latin typeface="Calibri"/>
+                <a:cs typeface="Calibri"/>
+              </a:rPr>
+              <a:t> </a:t>
+            </a:r>
+            <a:r>
+              <a:rPr sz="1800" b="1" spc="-10" dirty="0">
+                <a:solidFill>
+                  <a:srgbClr val="003366"/>
+                </a:solidFill>
+                <a:latin typeface="Calibri"/>
+                <a:cs typeface="Calibri"/>
+              </a:rPr>
+              <a:t>Ferramentas</a:t>
+            </a:r>
+            <a:r>
+              <a:rPr sz="1800" b="1" spc="-25" dirty="0">
+                <a:solidFill>
+                  <a:srgbClr val="003366"/>
+                </a:solidFill>
+                <a:latin typeface="Calibri"/>
+                <a:cs typeface="Calibri"/>
+              </a:rPr>
+              <a:t> </a:t>
+            </a:r>
+            <a:r>
+              <a:rPr sz="1800" b="1" spc="-10" dirty="0">
+                <a:solidFill>
+                  <a:srgbClr val="003366"/>
+                </a:solidFill>
+                <a:latin typeface="Calibri"/>
+                <a:cs typeface="Calibri"/>
+              </a:rPr>
+              <a:t>implementadas</a:t>
+            </a:r>
+            <a:endParaRPr sz="1800" dirty="0">
+              <a:latin typeface="Calibri"/>
+              <a:cs typeface="Calibri"/>
+            </a:endParaRPr>
+          </a:p>
+        </p:txBody>
+      </p:sp>
+      <p:sp>
+        <p:nvSpPr>
+          <p:cNvPr id="8" name="object 8"/>
+          <p:cNvSpPr txBox="1"/>
+          <p:nvPr/>
+        </p:nvSpPr>
+        <p:spPr>
+          <a:xfrm>
+            <a:off x="1018768" y="5288598"/>
+            <a:ext cx="2361565" cy="299720"/>
+          </a:xfrm>
+          <a:prstGeom prst="rect">
+            <a:avLst/>
+          </a:prstGeom>
+        </p:spPr>
+        <p:txBody>
+          <a:bodyPr vert="horz" wrap="square" lIns="0" tIns="12700" rIns="0" bIns="0" rtlCol="0">
+            <a:spAutoFit/>
+          </a:bodyPr>
+          <a:lstStyle/>
+          <a:p>
+            <a:pPr marL="12700">
+              <a:lnSpc>
+                <a:spcPct val="100000"/>
+              </a:lnSpc>
+              <a:spcBef>
+                <a:spcPts val="100"/>
+              </a:spcBef>
+            </a:pPr>
+            <a:r>
+              <a:rPr sz="1800" b="1" dirty="0">
+                <a:solidFill>
+                  <a:srgbClr val="003366"/>
+                </a:solidFill>
+                <a:latin typeface="Calibri"/>
+                <a:cs typeface="Calibri"/>
+              </a:rPr>
+              <a:t>5.</a:t>
+            </a:r>
+            <a:r>
+              <a:rPr sz="1800" b="1" spc="-15" dirty="0">
+                <a:solidFill>
+                  <a:srgbClr val="003366"/>
+                </a:solidFill>
+                <a:latin typeface="Calibri"/>
+                <a:cs typeface="Calibri"/>
+              </a:rPr>
+              <a:t> </a:t>
+            </a:r>
+            <a:r>
+              <a:rPr sz="1800" b="1" spc="-10" dirty="0">
+                <a:solidFill>
+                  <a:srgbClr val="003366"/>
+                </a:solidFill>
+                <a:latin typeface="Calibri"/>
+                <a:cs typeface="Calibri"/>
+              </a:rPr>
+              <a:t>Demonstração</a:t>
+            </a:r>
+            <a:r>
+              <a:rPr sz="1800" b="1" spc="-15" dirty="0">
+                <a:solidFill>
+                  <a:srgbClr val="003366"/>
+                </a:solidFill>
+                <a:latin typeface="Calibri"/>
+                <a:cs typeface="Calibri"/>
+              </a:rPr>
+              <a:t> </a:t>
+            </a:r>
+            <a:r>
+              <a:rPr sz="1800" b="1" dirty="0">
+                <a:solidFill>
+                  <a:srgbClr val="003366"/>
+                </a:solidFill>
+                <a:latin typeface="Calibri"/>
+                <a:cs typeface="Calibri"/>
+              </a:rPr>
+              <a:t>ao</a:t>
+            </a:r>
+            <a:r>
+              <a:rPr sz="1800" b="1" spc="-5" dirty="0">
+                <a:solidFill>
+                  <a:srgbClr val="003366"/>
+                </a:solidFill>
+                <a:latin typeface="Calibri"/>
+                <a:cs typeface="Calibri"/>
+              </a:rPr>
+              <a:t> </a:t>
+            </a:r>
+            <a:r>
+              <a:rPr sz="1800" b="1" spc="-20" dirty="0">
+                <a:solidFill>
+                  <a:srgbClr val="003366"/>
+                </a:solidFill>
+                <a:latin typeface="Calibri"/>
+                <a:cs typeface="Calibri"/>
+              </a:rPr>
+              <a:t>vivo</a:t>
+            </a:r>
+            <a:endParaRPr sz="1800" dirty="0">
+              <a:latin typeface="Calibri"/>
+              <a:cs typeface="Calibri"/>
+            </a:endParaRPr>
+          </a:p>
+        </p:txBody>
+      </p:sp>
+      <p:sp>
+        <p:nvSpPr>
+          <p:cNvPr id="9" name="object 9"/>
+          <p:cNvSpPr txBox="1"/>
+          <p:nvPr/>
+        </p:nvSpPr>
+        <p:spPr>
+          <a:xfrm>
+            <a:off x="6404330" y="1794788"/>
+            <a:ext cx="3604260" cy="299720"/>
+          </a:xfrm>
+          <a:prstGeom prst="rect">
+            <a:avLst/>
+          </a:prstGeom>
+        </p:spPr>
+        <p:txBody>
+          <a:bodyPr vert="horz" wrap="square" lIns="0" tIns="12700" rIns="0" bIns="0" rtlCol="0">
+            <a:spAutoFit/>
+          </a:bodyPr>
+          <a:lstStyle/>
+          <a:p>
+            <a:pPr marL="12700">
+              <a:lnSpc>
+                <a:spcPct val="100000"/>
+              </a:lnSpc>
+              <a:spcBef>
+                <a:spcPts val="100"/>
+              </a:spcBef>
+            </a:pPr>
+            <a:r>
+              <a:rPr sz="1800" b="1" dirty="0">
+                <a:solidFill>
+                  <a:srgbClr val="003366"/>
+                </a:solidFill>
+                <a:latin typeface="Calibri"/>
+                <a:cs typeface="Calibri"/>
+              </a:rPr>
+              <a:t>6.</a:t>
+            </a:r>
+            <a:r>
+              <a:rPr sz="1800" b="1" spc="-50" dirty="0">
+                <a:solidFill>
+                  <a:srgbClr val="003366"/>
+                </a:solidFill>
+                <a:latin typeface="Calibri"/>
+                <a:cs typeface="Calibri"/>
+              </a:rPr>
+              <a:t> </a:t>
+            </a:r>
+            <a:r>
+              <a:rPr sz="1800" b="1" dirty="0">
+                <a:solidFill>
+                  <a:srgbClr val="003366"/>
+                </a:solidFill>
+                <a:latin typeface="Calibri"/>
+                <a:cs typeface="Calibri"/>
+              </a:rPr>
+              <a:t>Conjunto</a:t>
+            </a:r>
+            <a:r>
+              <a:rPr sz="1800" b="1" spc="-40" dirty="0">
+                <a:solidFill>
+                  <a:srgbClr val="003366"/>
+                </a:solidFill>
+                <a:latin typeface="Calibri"/>
+                <a:cs typeface="Calibri"/>
+              </a:rPr>
+              <a:t> </a:t>
+            </a:r>
+            <a:r>
+              <a:rPr sz="1800" b="1" dirty="0">
+                <a:solidFill>
+                  <a:srgbClr val="003366"/>
+                </a:solidFill>
+                <a:latin typeface="Calibri"/>
+                <a:cs typeface="Calibri"/>
+              </a:rPr>
+              <a:t>de</a:t>
+            </a:r>
+            <a:r>
+              <a:rPr sz="1800" b="1" spc="-50" dirty="0">
+                <a:solidFill>
+                  <a:srgbClr val="003366"/>
+                </a:solidFill>
+                <a:latin typeface="Calibri"/>
+                <a:cs typeface="Calibri"/>
+              </a:rPr>
+              <a:t> </a:t>
+            </a:r>
+            <a:r>
+              <a:rPr sz="1800" b="1" dirty="0">
+                <a:solidFill>
+                  <a:srgbClr val="003366"/>
+                </a:solidFill>
+                <a:latin typeface="Calibri"/>
+                <a:cs typeface="Calibri"/>
+              </a:rPr>
+              <a:t>avaliação</a:t>
+            </a:r>
+            <a:r>
+              <a:rPr sz="1800" b="1" spc="-45" dirty="0">
+                <a:solidFill>
+                  <a:srgbClr val="003366"/>
+                </a:solidFill>
+                <a:latin typeface="Calibri"/>
+                <a:cs typeface="Calibri"/>
+              </a:rPr>
+              <a:t> </a:t>
+            </a:r>
+            <a:r>
+              <a:rPr sz="1800" b="1" spc="-10" dirty="0">
+                <a:solidFill>
+                  <a:srgbClr val="003366"/>
+                </a:solidFill>
+                <a:latin typeface="Calibri"/>
+                <a:cs typeface="Calibri"/>
+              </a:rPr>
+              <a:t>(benchmark)</a:t>
+            </a:r>
+            <a:endParaRPr sz="1800" dirty="0">
+              <a:latin typeface="Calibri"/>
+              <a:cs typeface="Calibri"/>
+            </a:endParaRPr>
+          </a:p>
+        </p:txBody>
+      </p:sp>
+      <p:sp>
+        <p:nvSpPr>
+          <p:cNvPr id="10" name="object 10"/>
+          <p:cNvSpPr txBox="1"/>
+          <p:nvPr/>
+        </p:nvSpPr>
+        <p:spPr>
+          <a:xfrm>
+            <a:off x="6401155" y="2665908"/>
+            <a:ext cx="2593975" cy="299720"/>
+          </a:xfrm>
+          <a:prstGeom prst="rect">
+            <a:avLst/>
+          </a:prstGeom>
+        </p:spPr>
+        <p:txBody>
+          <a:bodyPr vert="horz" wrap="square" lIns="0" tIns="12700" rIns="0" bIns="0" rtlCol="0">
+            <a:spAutoFit/>
+          </a:bodyPr>
+          <a:lstStyle/>
+          <a:p>
+            <a:pPr marL="12700">
+              <a:lnSpc>
+                <a:spcPct val="100000"/>
+              </a:lnSpc>
+              <a:spcBef>
+                <a:spcPts val="100"/>
+              </a:spcBef>
+            </a:pPr>
+            <a:r>
+              <a:rPr sz="1800" b="1" dirty="0">
+                <a:solidFill>
+                  <a:srgbClr val="003366"/>
+                </a:solidFill>
+                <a:latin typeface="Calibri"/>
+                <a:cs typeface="Calibri"/>
+              </a:rPr>
+              <a:t>7.</a:t>
+            </a:r>
+            <a:r>
+              <a:rPr sz="1800" b="1" spc="-55" dirty="0">
+                <a:solidFill>
+                  <a:srgbClr val="003366"/>
+                </a:solidFill>
+                <a:latin typeface="Calibri"/>
+                <a:cs typeface="Calibri"/>
+              </a:rPr>
+              <a:t> </a:t>
+            </a:r>
+            <a:r>
+              <a:rPr sz="1800" b="1" dirty="0">
+                <a:solidFill>
+                  <a:srgbClr val="003366"/>
+                </a:solidFill>
+                <a:latin typeface="Calibri"/>
+                <a:cs typeface="Calibri"/>
+              </a:rPr>
+              <a:t>Resultados</a:t>
+            </a:r>
+            <a:r>
+              <a:rPr sz="1800" b="1" spc="-45" dirty="0">
+                <a:solidFill>
+                  <a:srgbClr val="003366"/>
+                </a:solidFill>
+                <a:latin typeface="Calibri"/>
+                <a:cs typeface="Calibri"/>
+              </a:rPr>
+              <a:t> </a:t>
+            </a:r>
+            <a:r>
+              <a:rPr sz="1800" b="1" spc="-10" dirty="0">
+                <a:solidFill>
+                  <a:srgbClr val="003366"/>
+                </a:solidFill>
+                <a:latin typeface="Calibri"/>
+                <a:cs typeface="Calibri"/>
+              </a:rPr>
+              <a:t>quantitativos</a:t>
+            </a:r>
+            <a:endParaRPr sz="1800" dirty="0">
+              <a:latin typeface="Calibri"/>
+              <a:cs typeface="Calibri"/>
+            </a:endParaRPr>
+          </a:p>
+        </p:txBody>
+      </p:sp>
+      <p:sp>
+        <p:nvSpPr>
+          <p:cNvPr id="11" name="object 11"/>
+          <p:cNvSpPr txBox="1"/>
+          <p:nvPr/>
+        </p:nvSpPr>
+        <p:spPr>
+          <a:xfrm>
+            <a:off x="6401155" y="3540760"/>
+            <a:ext cx="2973070" cy="299720"/>
+          </a:xfrm>
+          <a:prstGeom prst="rect">
+            <a:avLst/>
+          </a:prstGeom>
+        </p:spPr>
+        <p:txBody>
+          <a:bodyPr vert="horz" wrap="square" lIns="0" tIns="12700" rIns="0" bIns="0" rtlCol="0">
+            <a:spAutoFit/>
+          </a:bodyPr>
+          <a:lstStyle/>
+          <a:p>
+            <a:pPr marL="12700">
+              <a:lnSpc>
+                <a:spcPct val="100000"/>
+              </a:lnSpc>
+              <a:spcBef>
+                <a:spcPts val="100"/>
+              </a:spcBef>
+            </a:pPr>
+            <a:r>
+              <a:rPr sz="1800" b="1" dirty="0">
+                <a:solidFill>
+                  <a:srgbClr val="003366"/>
+                </a:solidFill>
+                <a:latin typeface="Calibri"/>
+                <a:cs typeface="Calibri"/>
+              </a:rPr>
+              <a:t>8.</a:t>
+            </a:r>
+            <a:r>
+              <a:rPr sz="1800" b="1" spc="-20" dirty="0">
+                <a:solidFill>
+                  <a:srgbClr val="003366"/>
+                </a:solidFill>
+                <a:latin typeface="Calibri"/>
+                <a:cs typeface="Calibri"/>
+              </a:rPr>
+              <a:t> </a:t>
+            </a:r>
+            <a:r>
+              <a:rPr sz="1800" b="1" dirty="0">
+                <a:solidFill>
+                  <a:srgbClr val="003366"/>
+                </a:solidFill>
+                <a:latin typeface="Calibri"/>
+                <a:cs typeface="Calibri"/>
+              </a:rPr>
+              <a:t>Análise</a:t>
+            </a:r>
+            <a:r>
+              <a:rPr sz="1800" b="1" spc="-10" dirty="0">
+                <a:solidFill>
+                  <a:srgbClr val="003366"/>
+                </a:solidFill>
+                <a:latin typeface="Calibri"/>
+                <a:cs typeface="Calibri"/>
+              </a:rPr>
+              <a:t> </a:t>
+            </a:r>
+            <a:r>
+              <a:rPr sz="1800" b="1" dirty="0">
+                <a:solidFill>
+                  <a:srgbClr val="003366"/>
+                </a:solidFill>
+                <a:latin typeface="Calibri"/>
+                <a:cs typeface="Calibri"/>
+              </a:rPr>
+              <a:t>de</a:t>
+            </a:r>
+            <a:r>
+              <a:rPr sz="1800" b="1" spc="-15" dirty="0">
+                <a:solidFill>
+                  <a:srgbClr val="003366"/>
+                </a:solidFill>
+                <a:latin typeface="Calibri"/>
+                <a:cs typeface="Calibri"/>
+              </a:rPr>
+              <a:t> </a:t>
+            </a:r>
+            <a:r>
+              <a:rPr sz="1800" b="1" spc="-10" dirty="0">
+                <a:solidFill>
+                  <a:srgbClr val="003366"/>
+                </a:solidFill>
+                <a:latin typeface="Calibri"/>
+                <a:cs typeface="Calibri"/>
+              </a:rPr>
+              <a:t>trajetórias </a:t>
+            </a:r>
+            <a:r>
+              <a:rPr sz="1800" b="1" dirty="0">
+                <a:solidFill>
+                  <a:srgbClr val="003366"/>
+                </a:solidFill>
+                <a:latin typeface="Calibri"/>
+                <a:cs typeface="Calibri"/>
+              </a:rPr>
+              <a:t>e</a:t>
+            </a:r>
+            <a:r>
+              <a:rPr sz="1800" b="1" spc="-15" dirty="0">
+                <a:solidFill>
+                  <a:srgbClr val="003366"/>
+                </a:solidFill>
+                <a:latin typeface="Calibri"/>
+                <a:cs typeface="Calibri"/>
+              </a:rPr>
+              <a:t> </a:t>
+            </a:r>
+            <a:r>
+              <a:rPr sz="1800" b="1" spc="-20" dirty="0">
+                <a:solidFill>
+                  <a:srgbClr val="003366"/>
+                </a:solidFill>
+                <a:latin typeface="Calibri"/>
+                <a:cs typeface="Calibri"/>
+              </a:rPr>
+              <a:t>erros</a:t>
+            </a:r>
+            <a:endParaRPr sz="1800" dirty="0">
+              <a:latin typeface="Calibri"/>
+              <a:cs typeface="Calibri"/>
+            </a:endParaRPr>
+          </a:p>
+        </p:txBody>
+      </p:sp>
+      <p:sp>
+        <p:nvSpPr>
+          <p:cNvPr id="12" name="object 12"/>
+          <p:cNvSpPr txBox="1"/>
+          <p:nvPr/>
+        </p:nvSpPr>
+        <p:spPr>
+          <a:xfrm>
+            <a:off x="6401155" y="4415612"/>
+            <a:ext cx="1805305" cy="299720"/>
+          </a:xfrm>
+          <a:prstGeom prst="rect">
+            <a:avLst/>
+          </a:prstGeom>
+        </p:spPr>
+        <p:txBody>
+          <a:bodyPr vert="horz" wrap="square" lIns="0" tIns="12700" rIns="0" bIns="0" rtlCol="0">
+            <a:spAutoFit/>
+          </a:bodyPr>
+          <a:lstStyle/>
+          <a:p>
+            <a:pPr marL="12700">
+              <a:lnSpc>
+                <a:spcPct val="100000"/>
+              </a:lnSpc>
+              <a:spcBef>
+                <a:spcPts val="100"/>
+              </a:spcBef>
+            </a:pPr>
+            <a:r>
+              <a:rPr sz="1800" b="1" dirty="0">
+                <a:solidFill>
+                  <a:srgbClr val="003366"/>
+                </a:solidFill>
+                <a:latin typeface="Calibri"/>
+                <a:cs typeface="Calibri"/>
+              </a:rPr>
+              <a:t>9.</a:t>
+            </a:r>
+            <a:r>
+              <a:rPr sz="1800" b="1" spc="-25" dirty="0">
+                <a:solidFill>
+                  <a:srgbClr val="003366"/>
+                </a:solidFill>
+                <a:latin typeface="Calibri"/>
+                <a:cs typeface="Calibri"/>
+              </a:rPr>
+              <a:t> </a:t>
+            </a:r>
+            <a:r>
+              <a:rPr sz="1800" b="1" dirty="0">
+                <a:solidFill>
+                  <a:srgbClr val="003366"/>
+                </a:solidFill>
+                <a:latin typeface="Calibri"/>
+                <a:cs typeface="Calibri"/>
+              </a:rPr>
+              <a:t>Discussão</a:t>
+            </a:r>
+            <a:r>
+              <a:rPr sz="1800" b="1" spc="-30" dirty="0">
+                <a:solidFill>
+                  <a:srgbClr val="003366"/>
+                </a:solidFill>
+                <a:latin typeface="Calibri"/>
+                <a:cs typeface="Calibri"/>
+              </a:rPr>
+              <a:t> </a:t>
+            </a:r>
+            <a:r>
+              <a:rPr sz="1800" b="1" spc="-10" dirty="0">
+                <a:solidFill>
+                  <a:srgbClr val="003366"/>
+                </a:solidFill>
+                <a:latin typeface="Calibri"/>
+                <a:cs typeface="Calibri"/>
+              </a:rPr>
+              <a:t>crítica</a:t>
+            </a:r>
+            <a:endParaRPr sz="1800" dirty="0">
+              <a:latin typeface="Calibri"/>
+              <a:cs typeface="Calibri"/>
+            </a:endParaRPr>
+          </a:p>
+        </p:txBody>
+      </p:sp>
+      <p:sp>
+        <p:nvSpPr>
+          <p:cNvPr id="13" name="object 13"/>
+          <p:cNvSpPr txBox="1"/>
+          <p:nvPr/>
+        </p:nvSpPr>
+        <p:spPr>
+          <a:xfrm>
+            <a:off x="6401155" y="5288598"/>
+            <a:ext cx="3282315" cy="299720"/>
+          </a:xfrm>
+          <a:prstGeom prst="rect">
+            <a:avLst/>
+          </a:prstGeom>
+        </p:spPr>
+        <p:txBody>
+          <a:bodyPr vert="horz" wrap="square" lIns="0" tIns="12700" rIns="0" bIns="0" rtlCol="0">
+            <a:spAutoFit/>
+          </a:bodyPr>
+          <a:lstStyle/>
+          <a:p>
+            <a:pPr marL="12700">
+              <a:lnSpc>
+                <a:spcPct val="100000"/>
+              </a:lnSpc>
+              <a:spcBef>
+                <a:spcPts val="100"/>
+              </a:spcBef>
+            </a:pPr>
+            <a:r>
+              <a:rPr sz="1800" b="1" dirty="0">
+                <a:solidFill>
+                  <a:srgbClr val="003366"/>
+                </a:solidFill>
+                <a:latin typeface="Calibri"/>
+                <a:cs typeface="Calibri"/>
+              </a:rPr>
+              <a:t>10.</a:t>
+            </a:r>
+            <a:r>
+              <a:rPr sz="1800" b="1" spc="-35" dirty="0">
+                <a:solidFill>
+                  <a:srgbClr val="003366"/>
+                </a:solidFill>
+                <a:latin typeface="Calibri"/>
+                <a:cs typeface="Calibri"/>
+              </a:rPr>
+              <a:t> </a:t>
+            </a:r>
+            <a:r>
+              <a:rPr sz="1800" b="1" dirty="0">
+                <a:solidFill>
+                  <a:srgbClr val="003366"/>
+                </a:solidFill>
+                <a:latin typeface="Calibri"/>
+                <a:cs typeface="Calibri"/>
+              </a:rPr>
+              <a:t>Conclusões</a:t>
+            </a:r>
+            <a:r>
+              <a:rPr sz="1800" b="1" spc="-30" dirty="0">
+                <a:solidFill>
+                  <a:srgbClr val="003366"/>
+                </a:solidFill>
+                <a:latin typeface="Calibri"/>
+                <a:cs typeface="Calibri"/>
+              </a:rPr>
+              <a:t> </a:t>
+            </a:r>
+            <a:r>
+              <a:rPr sz="1800" b="1" dirty="0">
+                <a:solidFill>
+                  <a:srgbClr val="003366"/>
+                </a:solidFill>
+                <a:latin typeface="Calibri"/>
+                <a:cs typeface="Calibri"/>
+              </a:rPr>
+              <a:t>e</a:t>
+            </a:r>
+            <a:r>
+              <a:rPr sz="1800" b="1" spc="-35" dirty="0">
+                <a:solidFill>
+                  <a:srgbClr val="003366"/>
+                </a:solidFill>
+                <a:latin typeface="Calibri"/>
+                <a:cs typeface="Calibri"/>
+              </a:rPr>
+              <a:t> </a:t>
+            </a:r>
+            <a:r>
+              <a:rPr sz="1800" b="1" dirty="0">
+                <a:solidFill>
+                  <a:srgbClr val="003366"/>
+                </a:solidFill>
+                <a:latin typeface="Calibri"/>
+                <a:cs typeface="Calibri"/>
+              </a:rPr>
+              <a:t>trabalhos</a:t>
+            </a:r>
+            <a:r>
+              <a:rPr sz="1800" b="1" spc="-25" dirty="0">
+                <a:solidFill>
+                  <a:srgbClr val="003366"/>
+                </a:solidFill>
+                <a:latin typeface="Calibri"/>
+                <a:cs typeface="Calibri"/>
+              </a:rPr>
+              <a:t> </a:t>
+            </a:r>
+            <a:r>
+              <a:rPr sz="1800" b="1" spc="-10" dirty="0">
+                <a:solidFill>
+                  <a:srgbClr val="003366"/>
+                </a:solidFill>
+                <a:latin typeface="Calibri"/>
+                <a:cs typeface="Calibri"/>
+              </a:rPr>
+              <a:t>futuros</a:t>
+            </a:r>
+            <a:endParaRPr sz="1800" dirty="0">
+              <a:latin typeface="Calibri"/>
+              <a:cs typeface="Calibri"/>
+            </a:endParaRPr>
+          </a:p>
+        </p:txBody>
+      </p:sp>
+      <p:sp>
+        <p:nvSpPr>
+          <p:cNvPr id="18" name="object 18"/>
+          <p:cNvSpPr txBox="1">
+            <a:spLocks noGrp="1"/>
+          </p:cNvSpPr>
+          <p:nvPr>
+            <p:ph type="ftr" sz="quarter" idx="5"/>
+          </p:nvPr>
+        </p:nvSpPr>
+        <p:spPr>
+          <a:prstGeom prst="rect">
+            <a:avLst/>
+          </a:prstGeom>
+        </p:spPr>
+        <p:txBody>
+          <a:bodyPr vert="horz" wrap="square" lIns="0" tIns="6985" rIns="0" bIns="0" rtlCol="0">
+            <a:spAutoFit/>
+          </a:bodyPr>
+          <a:lstStyle/>
+          <a:p>
+            <a:pPr marL="12700">
+              <a:lnSpc>
+                <a:spcPct val="100000"/>
+              </a:lnSpc>
+              <a:spcBef>
+                <a:spcPts val="55"/>
+              </a:spcBef>
+            </a:pPr>
+            <a:r>
+              <a:rPr spc="-10" dirty="0"/>
+              <a:t>Fatec</a:t>
+            </a:r>
+            <a:r>
+              <a:rPr spc="-30" dirty="0"/>
+              <a:t> </a:t>
+            </a:r>
+            <a:r>
+              <a:rPr dirty="0"/>
+              <a:t>Ourinhos</a:t>
+            </a:r>
+            <a:r>
+              <a:rPr spc="-10" dirty="0"/>
+              <a:t> </a:t>
+            </a:r>
+            <a:r>
+              <a:rPr dirty="0"/>
+              <a:t>|</a:t>
+            </a:r>
+            <a:r>
+              <a:rPr spc="-30" dirty="0"/>
+              <a:t> </a:t>
+            </a:r>
+            <a:r>
+              <a:rPr dirty="0"/>
+              <a:t>Ciência</a:t>
+            </a:r>
+            <a:r>
+              <a:rPr spc="-15" dirty="0"/>
+              <a:t> </a:t>
+            </a:r>
+            <a:r>
+              <a:rPr dirty="0"/>
+              <a:t>de</a:t>
+            </a:r>
+            <a:r>
+              <a:rPr spc="-25" dirty="0"/>
+              <a:t> </a:t>
+            </a:r>
+            <a:r>
+              <a:rPr spc="-20" dirty="0"/>
+              <a:t>Dados</a:t>
+            </a:r>
+          </a:p>
+        </p:txBody>
+      </p:sp>
+      <p:sp>
+        <p:nvSpPr>
+          <p:cNvPr id="19" name="object 19"/>
+          <p:cNvSpPr txBox="1">
+            <a:spLocks noGrp="1"/>
+          </p:cNvSpPr>
+          <p:nvPr>
+            <p:ph type="dt" sz="half" idx="6"/>
+          </p:nvPr>
+        </p:nvSpPr>
+        <p:spPr>
+          <a:prstGeom prst="rect">
+            <a:avLst/>
+          </a:prstGeom>
+        </p:spPr>
+        <p:txBody>
+          <a:bodyPr vert="horz" wrap="square" lIns="0" tIns="6985" rIns="0" bIns="0" rtlCol="0">
+            <a:spAutoFit/>
+          </a:bodyPr>
+          <a:lstStyle/>
+          <a:p>
+            <a:pPr marL="12700">
+              <a:lnSpc>
+                <a:spcPct val="100000"/>
+              </a:lnSpc>
+              <a:spcBef>
+                <a:spcPts val="55"/>
+              </a:spcBef>
+            </a:pPr>
+            <a:r>
+              <a:rPr spc="-10" dirty="0"/>
+              <a:t>Trabalho</a:t>
+            </a:r>
+            <a:r>
+              <a:rPr spc="-25" dirty="0"/>
+              <a:t> </a:t>
+            </a:r>
+            <a:r>
+              <a:rPr dirty="0"/>
+              <a:t>Final</a:t>
+            </a:r>
+            <a:r>
+              <a:rPr spc="-5" dirty="0"/>
+              <a:t> </a:t>
+            </a:r>
+            <a:r>
+              <a:rPr dirty="0"/>
+              <a:t>-</a:t>
+            </a:r>
+            <a:r>
+              <a:rPr spc="-25" dirty="0"/>
+              <a:t> </a:t>
+            </a:r>
+            <a:r>
+              <a:rPr dirty="0"/>
+              <a:t>5º</a:t>
+            </a:r>
+            <a:r>
+              <a:rPr spc="-10" dirty="0"/>
+              <a:t> Semestre</a:t>
+            </a:r>
+          </a:p>
+        </p:txBody>
+      </p:sp>
+      <p:sp>
+        <p:nvSpPr>
+          <p:cNvPr id="20" name="object 20"/>
+          <p:cNvSpPr txBox="1">
+            <a:spLocks noGrp="1"/>
+          </p:cNvSpPr>
+          <p:nvPr>
+            <p:ph type="sldNum" sz="quarter" idx="7"/>
+          </p:nvPr>
+        </p:nvSpPr>
+        <p:spPr>
+          <a:xfrm>
+            <a:off x="11275097" y="6507344"/>
+            <a:ext cx="351790" cy="145553"/>
+          </a:xfrm>
+          <a:prstGeom prst="rect">
+            <a:avLst/>
+          </a:prstGeom>
+        </p:spPr>
+        <p:txBody>
+          <a:bodyPr vert="horz" wrap="square" lIns="0" tIns="6985" rIns="0" bIns="0" rtlCol="0">
+            <a:spAutoFit/>
+          </a:bodyPr>
+          <a:lstStyle/>
+          <a:p>
+            <a:pPr marL="12700">
+              <a:lnSpc>
+                <a:spcPct val="100000"/>
+              </a:lnSpc>
+              <a:spcBef>
+                <a:spcPts val="55"/>
+              </a:spcBef>
+            </a:pPr>
+            <a:fld id="{81D60167-4931-47E6-BA6A-407CBD079E47}" type="slidenum">
+              <a:rPr dirty="0"/>
+              <a:t>2</a:t>
+            </a:fld>
+            <a:r>
+              <a:rPr spc="-15" dirty="0"/>
+              <a:t> </a:t>
+            </a:r>
+            <a:r>
+              <a:rPr dirty="0"/>
+              <a:t>/</a:t>
+            </a:r>
+            <a:r>
+              <a:rPr spc="5" dirty="0"/>
+              <a:t> </a:t>
+            </a:r>
+            <a:r>
+              <a:rPr lang="pt-BR" spc="-25" dirty="0"/>
+              <a:t>18</a:t>
+            </a:r>
+            <a:endParaRPr spc="-25" dirty="0"/>
+          </a:p>
+        </p:txBody>
+      </p:sp>
+    </p:spTree>
+  </p:cSld>
+  <p:clrMapOvr>
+    <a:masterClrMapping/>
+  </p:clrMapOvr>
+</p:sld>
+</file>
+
+<file path=ppt/slides/slide20.xml><?xml version="1.0" encoding="utf-8"?>
+<p:sld xmlns:a="http://schemas.openxmlformats.org/drawingml/2006/main" xmlns:r="http://schemas.openxmlformats.org/officeDocument/2006/relationships" xmlns:p="http://schemas.openxmlformats.org/presentationml/2006/main">
+  <p:cSld>
+    <p:spTree>
+      <p:nvGrpSpPr>
+        <p:cNvPr id="1" name=""/>
+        <p:cNvGrpSpPr/>
+        <p:nvPr/>
+      </p:nvGrpSpPr>
+      <p:grpSpPr>
+        <a:xfrm>
+          <a:off x="0" y="0"/>
+          <a:ext cx="0" cy="0"/>
+          <a:chOff x="0" y="0"/>
+          <a:chExt cx="0" cy="0"/>
+        </a:xfrm>
+      </p:grpSpPr>
+      <p:sp>
+        <p:nvSpPr>
+          <p:cNvPr id="2" name="object 2" descr="$PPTXTitle"/>
+          <p:cNvSpPr txBox="1">
+            <a:spLocks noGrp="1"/>
+          </p:cNvSpPr>
+          <p:nvPr>
+            <p:ph type="title"/>
+          </p:nvPr>
+        </p:nvSpPr>
+        <p:spPr>
+          <a:prstGeom prst="rect">
+            <a:avLst/>
+          </a:prstGeom>
+        </p:spPr>
+        <p:txBody>
+          <a:bodyPr vert="horz" wrap="square" lIns="0" tIns="12700" rIns="0" bIns="0" rtlCol="0">
+            <a:spAutoFit/>
+          </a:bodyPr>
+          <a:lstStyle/>
+          <a:p>
+            <a:pPr marL="12700">
+              <a:lnSpc>
+                <a:spcPct val="100000"/>
+              </a:lnSpc>
+              <a:spcBef>
+                <a:spcPts val="100"/>
+              </a:spcBef>
+            </a:pPr>
+            <a:r>
+              <a:rPr spc="-10" dirty="0"/>
+              <a:t>Referências</a:t>
+            </a:r>
+          </a:p>
+        </p:txBody>
+      </p:sp>
+      <p:sp>
+        <p:nvSpPr>
+          <p:cNvPr id="8" name="Espaço Reservado para Texto 7">
+            <a:extLst>
+              <a:ext uri="{FF2B5EF4-FFF2-40B4-BE49-F238E27FC236}">
+                <a16:creationId xmlns:a16="http://schemas.microsoft.com/office/drawing/2014/main" id="{DEE6DBCE-439B-3FC3-CC3E-0B2F854003A6}"/>
+              </a:ext>
+            </a:extLst>
+          </p:cNvPr>
+          <p:cNvSpPr>
+            <a:spLocks noGrp="1"/>
+          </p:cNvSpPr>
+          <p:nvPr>
+            <p:ph type="body" idx="1"/>
+          </p:nvPr>
+        </p:nvSpPr>
+        <p:spPr>
+          <a:xfrm>
+            <a:off x="457200" y="1563924"/>
+            <a:ext cx="11329035" cy="4839145"/>
+          </a:xfrm>
+        </p:spPr>
+        <p:txBody>
+          <a:bodyPr/>
+          <a:lstStyle/>
+          <a:p>
             <a:pPr marL="12700" marR="5080">
               <a:lnSpc>
                 <a:spcPct val="238800"/>
               </a:lnSpc>
             </a:pPr>
             <a:r>
-              <a:rPr lang="pt-BR" sz="1300" b="1" i="1" spc="-10" dirty="0">
+              <a:rPr lang="pt-BR" sz="1100" b="1" i="1" spc="-10" dirty="0">
                 <a:solidFill>
                   <a:srgbClr val="191919"/>
                 </a:solidFill>
-                <a:latin typeface="Calibri"/>
-                <a:cs typeface="Calibri"/>
-              </a:rPr>
-              <a:t>OPENAI</a:t>
-            </a:r>
-            <a:r>
-              <a:rPr lang="pt-BR" sz="1300" i="1" spc="-10" dirty="0">
+                <a:latin typeface="+mj-lt"/>
+                <a:cs typeface="Calibri"/>
+              </a:rPr>
+              <a:t>DEEPSEEK</a:t>
+            </a:r>
+            <a:r>
+              <a:rPr lang="pt-BR" sz="1100" i="1" spc="-10" dirty="0">
                 <a:solidFill>
                   <a:srgbClr val="191919"/>
                 </a:solidFill>
-                <a:latin typeface="Calibri"/>
+                <a:latin typeface="+mj-lt"/>
                 <a:cs typeface="Calibri"/>
               </a:rPr>
               <a:t>. </a:t>
             </a:r>
             <a:r>
-              <a:rPr lang="pt-BR" sz="1300" i="1" spc="-10" dirty="0" err="1">
+              <a:rPr lang="pt-BR" sz="1100" i="1" spc="-10" dirty="0" err="1">
                 <a:solidFill>
                   <a:srgbClr val="191919"/>
                 </a:solidFill>
-                <a:latin typeface="Calibri"/>
-                <a:cs typeface="Calibri"/>
-              </a:rPr>
-              <a:t>Function</a:t>
-            </a:r>
-            <a:r>
-              <a:rPr lang="pt-BR" sz="1300" i="1" spc="-10" dirty="0">
+                <a:latin typeface="+mj-lt"/>
+                <a:cs typeface="Calibri"/>
+              </a:rPr>
+              <a:t>DeepSeek</a:t>
+            </a:r>
+            <a:r>
+              <a:rPr lang="pt-BR" sz="1100" i="1" spc="-10" dirty="0">
                 <a:solidFill>
                   <a:srgbClr val="191919"/>
                 </a:solidFill>
-                <a:latin typeface="Calibri"/>
-                <a:cs typeface="Calibri"/>
-              </a:rPr>
-              <a:t> </a:t>
-            </a:r>
-            <a:r>
-              <a:rPr lang="pt-BR" sz="1300" i="1" spc="-10" dirty="0" err="1">
+                <a:latin typeface="+mj-lt"/>
+                <a:cs typeface="Calibri"/>
+              </a:rPr>
+              <a:t> API </a:t>
+            </a:r>
+            <a:r>
+              <a:rPr lang="pt-BR" sz="1100" i="1" spc="-10" dirty="0" err="1">
                 <a:solidFill>
                   <a:srgbClr val="191919"/>
                 </a:solidFill>
-                <a:latin typeface="Calibri"/>
-                <a:cs typeface="Calibri"/>
-              </a:rPr>
-              <a:t>calling</a:t>
-            </a:r>
-            <a:r>
-              <a:rPr lang="pt-BR" sz="1300" i="1" spc="-10" dirty="0">
+                <a:latin typeface="+mj-lt"/>
+                <a:cs typeface="Calibri"/>
+              </a:rPr>
+              <a:t>Documentation</a:t>
+            </a:r>
+            <a:r>
+              <a:rPr lang="pt-BR" sz="1100" i="1" spc="-10" dirty="0">
                 <a:solidFill>
                   <a:srgbClr val="191919"/>
                 </a:solidFill>
-                <a:latin typeface="Calibri"/>
-                <a:cs typeface="Calibri"/>
-              </a:rPr>
-              <a:t> and tool use. </a:t>
-            </a:r>
-            <a:r>
-              <a:rPr lang="pt-BR" sz="1300" i="1" spc="-10" dirty="0" err="1">
+                <a:latin typeface="+mj-lt"/>
+                <a:cs typeface="Calibri"/>
+              </a:rPr>
+              <a:t>. Documentação da API </a:t>
+            </a:r>
+            <a:r>
+              <a:rPr lang="pt-BR" sz="1100" i="1" spc="-10" dirty="0" err="1">
                 <a:solidFill>
                   <a:srgbClr val="191919"/>
                 </a:solidFill>
-                <a:latin typeface="Calibri"/>
-                <a:cs typeface="Calibri"/>
-              </a:rPr>
-              <a:t>Documentacão</a:t>
-            </a:r>
-            <a:r>
-              <a:rPr lang="pt-BR" sz="1300" i="1" spc="-10" dirty="0">
+                <a:latin typeface="+mj-lt"/>
+                <a:cs typeface="Calibri"/>
+              </a:rPr>
+              <a:t>DeepSeek</a:t>
+            </a:r>
+            <a:r>
+              <a:rPr lang="pt-BR" sz="1100" i="1" spc="-10" dirty="0">
                 <a:solidFill>
                   <a:srgbClr val="191919"/>
                 </a:solidFill>
-                <a:latin typeface="Calibri"/>
-                <a:cs typeface="Calibri"/>
-              </a:rPr>
-              <a:t> técnica de APIs para  modelos de linguagem. Disponível em: </a:t>
-            </a:r>
-            <a:r>
-              <a:rPr lang="pt-BR" sz="1300" i="1" spc="-10" dirty="0">
-                <a:solidFill>
-                  <a:srgbClr val="191919"/>
-                </a:solidFill>
-                <a:latin typeface="Calibri"/>
-                <a:cs typeface="Calibri"/>
-                <a:hlinkClick r:id="rId2"/>
-              </a:rPr>
-              <a:t>https://platform.openai.com/docs</a:t>
-            </a:r>
-            <a:r>
-              <a:rPr lang="pt-BR" sz="1300" i="1" spc="-10" dirty="0">
-                <a:solidFill>
-                  <a:srgbClr val="191919"/>
-                </a:solidFill>
-                <a:latin typeface="Calibri"/>
-                <a:cs typeface="Calibri"/>
-              </a:rPr>
-              <a:t>. Acesso em: 2026. </a:t>
+                <a:latin typeface="+mj-lt"/>
+                <a:cs typeface="Calibri"/>
+              </a:rPr>
+              <a:t>. Disponível em: https://api-docs.deepseek.com/. Acesso em: 2026. </a:t>
             </a:r>
           </a:p>
           <a:p>
@@ -9127,84 +10734,84 @@
               </a:lnSpc>
             </a:pPr>
             <a:r>
-              <a:rPr lang="pt-BR" sz="1300" b="1" i="1" spc="-10" dirty="0">
+              <a:rPr lang="pt-BR" sz="1100" b="1" i="1" spc="-10" dirty="0">
                 <a:solidFill>
                   <a:srgbClr val="191919"/>
                 </a:solidFill>
-                <a:latin typeface="Calibri"/>
-                <a:cs typeface="Calibri"/>
-              </a:rPr>
-              <a:t>DEEPSEEK</a:t>
-            </a:r>
-            <a:r>
-              <a:rPr lang="pt-BR" sz="1300" i="1" spc="-10" dirty="0">
+                <a:latin typeface="+mj-lt"/>
+                <a:cs typeface="Calibri"/>
+              </a:rPr>
+              <a:t>MCKINNEY, Wes.</a:t>
+            </a:r>
+            <a:r>
+              <a:rPr lang="pt-BR" sz="1100" i="1" spc="-10" dirty="0">
                 <a:solidFill>
                   <a:srgbClr val="191919"/>
                 </a:solidFill>
-                <a:latin typeface="Calibri"/>
-                <a:cs typeface="Calibri"/>
-              </a:rPr>
-              <a:t>. </a:t>
-            </a:r>
-            <a:r>
-              <a:rPr lang="pt-BR" sz="1300" i="1" spc="-10" dirty="0" err="1">
+                <a:latin typeface="+mj-lt"/>
+                <a:cs typeface="Calibri"/>
+              </a:rPr>
+              <a:t> Python for Data </a:t>
+            </a:r>
+            <a:r>
+              <a:rPr lang="pt-BR" sz="1100" i="1" spc="-10" dirty="0" err="1">
                 <a:solidFill>
                   <a:srgbClr val="191919"/>
                 </a:solidFill>
-                <a:latin typeface="Calibri"/>
-                <a:cs typeface="Calibri"/>
-              </a:rPr>
-              <a:t>DeepSeek</a:t>
-            </a:r>
-            <a:r>
-              <a:rPr lang="pt-BR" sz="1300" i="1" spc="-10" dirty="0">
+                <a:latin typeface="+mj-lt"/>
+                <a:cs typeface="Calibri"/>
+              </a:rPr>
+              <a:t>Analysis</a:t>
+            </a:r>
+            <a:r>
+              <a:rPr lang="pt-BR" sz="1100" i="1" spc="-10" dirty="0">
                 <a:solidFill>
                   <a:srgbClr val="191919"/>
                 </a:solidFill>
-                <a:latin typeface="Calibri"/>
-                <a:cs typeface="Calibri"/>
-              </a:rPr>
-              <a:t> API </a:t>
-            </a:r>
-            <a:r>
-              <a:rPr lang="pt-BR" sz="1300" i="1" spc="-10" dirty="0" err="1">
+                <a:latin typeface="+mj-lt"/>
+                <a:cs typeface="Calibri"/>
+              </a:rPr>
+              <a:t>. 3. ed. Sebastopol: O’Reilly Media, 2022. PANDAS DEVELOPMENT TEAM. Pandas </a:t>
+            </a:r>
+            <a:r>
+              <a:rPr lang="pt-BR" sz="1100" i="1" spc="-10" dirty="0" err="1">
                 <a:solidFill>
                   <a:srgbClr val="191919"/>
                 </a:solidFill>
-                <a:latin typeface="Calibri"/>
-                <a:cs typeface="Calibri"/>
-              </a:rPr>
-              <a:t>Documentation</a:t>
-            </a:r>
-            <a:r>
-              <a:rPr lang="pt-BR" sz="1300" i="1" spc="-10" dirty="0">
+                <a:latin typeface="+mj-lt"/>
+                <a:cs typeface="Calibri"/>
+              </a:rPr>
+              <a:t>documentation</a:t>
+            </a:r>
+            <a:r>
+              <a:rPr lang="pt-BR" sz="1100" i="1" spc="-10" dirty="0">
                 <a:solidFill>
                   <a:srgbClr val="191919"/>
                 </a:solidFill>
-                <a:latin typeface="Calibri"/>
-                <a:cs typeface="Calibri"/>
-              </a:rPr>
-              <a:t>. Documentação da API </a:t>
-            </a:r>
-            <a:r>
-              <a:rPr lang="pt-BR" sz="1300" i="1" spc="-10" dirty="0" err="1">
+                <a:latin typeface="+mj-lt"/>
+                <a:cs typeface="Calibri"/>
+              </a:rPr>
+              <a:t>. Disponível em: https://pandas.pydata.org/</a:t>
+            </a:r>
+            <a:r>
+              <a:rPr lang="pt-BR" sz="1100" i="1" spc="-10" dirty="0" err="1">
                 <a:solidFill>
                   <a:srgbClr val="191919"/>
                 </a:solidFill>
-                <a:latin typeface="Calibri"/>
-                <a:cs typeface="Calibri"/>
-              </a:rPr>
-              <a:t>DeepSeek</a:t>
-            </a:r>
-            <a:r>
-              <a:rPr lang="pt-BR" sz="1300" i="1" spc="-10" dirty="0">
+                <a:latin typeface="+mj-lt"/>
+                <a:cs typeface="Calibri"/>
+              </a:rPr>
+              <a:t>docs</a:t>
+            </a:r>
+            <a:r>
+              <a:rPr lang="pt-BR" sz="1100" i="1" spc="-10" dirty="0">
                 <a:solidFill>
                   <a:srgbClr val="191919"/>
                 </a:solidFill>
-                <a:latin typeface="Calibri"/>
-                <a:cs typeface="Calibri"/>
-              </a:rPr>
-              <a:t>. Disponível em: https://api-docs.deepseek.com/. Acesso em: 2026. </a:t>
+                <a:latin typeface="+mj-lt"/>
+                <a:cs typeface="Calibri"/>
+              </a:rPr>
+              <a:t>/. Acesso em: 2026. </a:t>
             </a:r>
           </a:p>
           <a:p>
@@ -9214,84 +10821,64 @@
               </a:lnSpc>
             </a:pPr>
             <a:r>
-              <a:rPr lang="pt-BR" sz="1300" b="1" i="1" spc="-10" dirty="0">
+              <a:rPr lang="pt-BR" sz="1100" b="1" i="1" spc="-10" dirty="0">
                 <a:solidFill>
                   <a:srgbClr val="191919"/>
                 </a:solidFill>
-                <a:latin typeface="Calibri"/>
-                <a:cs typeface="Calibri"/>
-              </a:rPr>
-              <a:t>MCKINNEY, Wes.</a:t>
-            </a:r>
-            <a:r>
-              <a:rPr lang="pt-BR" sz="1300" i="1" spc="-10" dirty="0">
+                <a:latin typeface="+mj-lt"/>
+                <a:cs typeface="Calibri"/>
+              </a:rPr>
+              <a:t>STREAMLIT.</a:t>
+            </a:r>
+            <a:r>
+              <a:rPr lang="pt-BR" sz="1100" i="1" spc="-10" dirty="0">
                 <a:solidFill>
                   <a:srgbClr val="191919"/>
                 </a:solidFill>
-                <a:latin typeface="Calibri"/>
-                <a:cs typeface="Calibri"/>
-              </a:rPr>
-              <a:t> Python for Data </a:t>
-            </a:r>
-            <a:r>
-              <a:rPr lang="pt-BR" sz="1300" i="1" spc="-10" dirty="0" err="1">
+                <a:latin typeface="+mj-lt"/>
+                <a:cs typeface="Calibri"/>
+              </a:rPr>
+              <a:t> </a:t>
+            </a:r>
+            <a:r>
+              <a:rPr lang="pt-BR" sz="1100" i="1" spc="-10" dirty="0" err="1">
                 <a:solidFill>
                   <a:srgbClr val="191919"/>
                 </a:solidFill>
-                <a:latin typeface="Calibri"/>
-                <a:cs typeface="Calibri"/>
-              </a:rPr>
-              <a:t>Analysis</a:t>
-            </a:r>
-            <a:r>
-              <a:rPr lang="pt-BR" sz="1300" i="1" spc="-10" dirty="0">
+                <a:latin typeface="+mj-lt"/>
+                <a:cs typeface="Calibri"/>
+              </a:rPr>
+              <a:t>Streamlit</a:t>
+            </a:r>
+            <a:r>
+              <a:rPr lang="pt-BR" sz="1100" i="1" spc="-10" dirty="0">
                 <a:solidFill>
                   <a:srgbClr val="191919"/>
                 </a:solidFill>
-                <a:latin typeface="Calibri"/>
-                <a:cs typeface="Calibri"/>
-              </a:rPr>
-              <a:t>. 3. ed. Sebastopol: O’Reilly Media, 2022. PANDAS DEVELOPMENT TEAM. Pandas </a:t>
-            </a:r>
-            <a:r>
-              <a:rPr lang="pt-BR" sz="1300" i="1" spc="-10" dirty="0" err="1">
+                <a:latin typeface="+mj-lt"/>
+                <a:cs typeface="Calibri"/>
+              </a:rPr>
+              <a:t> </a:t>
+            </a:r>
+            <a:r>
+              <a:rPr lang="pt-BR" sz="1100" i="1" spc="-10" dirty="0" err="1">
                 <a:solidFill>
                   <a:srgbClr val="191919"/>
                 </a:solidFill>
-                <a:latin typeface="Calibri"/>
+                <a:latin typeface="+mj-lt"/>
                 <a:cs typeface="Calibri"/>
               </a:rPr>
               <a:t>documentation</a:t>
             </a:r>
             <a:r>
-              <a:rPr lang="pt-BR" sz="1300" i="1" spc="-10" dirty="0">
+              <a:rPr lang="pt-BR" sz="1100" i="1" spc="-10" dirty="0">
                 <a:solidFill>
                   <a:srgbClr val="191919"/>
                 </a:solidFill>
-                <a:latin typeface="Calibri"/>
-                <a:cs typeface="Calibri"/>
-              </a:rPr>
-              <a:t>. Disponível em: https://pandas.pydata.org/</a:t>
-            </a:r>
-            <a:r>
-              <a:rPr lang="pt-BR" sz="1300" i="1" spc="-10" dirty="0" err="1">
-                <a:solidFill>
-                  <a:srgbClr val="191919"/>
-                </a:solidFill>
-                <a:latin typeface="Calibri"/>
-                <a:cs typeface="Calibri"/>
-              </a:rPr>
-              <a:t>docs</a:t>
-            </a:r>
-            <a:r>
-              <a:rPr lang="pt-BR" sz="1300" i="1" spc="-10" dirty="0">
-                <a:solidFill>
-                  <a:srgbClr val="191919"/>
-                </a:solidFill>
-                <a:latin typeface="Calibri"/>
-                <a:cs typeface="Calibri"/>
-              </a:rPr>
-              <a:t>/. Acesso em: 2026. </a:t>
+                <a:latin typeface="+mj-lt"/>
+                <a:cs typeface="Calibri"/>
+              </a:rPr>
+              <a:t>. Disponível em: https://docs.streamlit.io/. Acesso em: 2026. </a:t>
             </a:r>
           </a:p>
           <a:p>
@@ -9301,102 +10888,236 @@
               </a:lnSpc>
             </a:pPr>
             <a:r>
-              <a:rPr lang="pt-BR" sz="1300" b="1" i="1" spc="-10" dirty="0">
-                <a:solidFill>
-                  <a:srgbClr val="191919"/>
-                </a:solidFill>
-                <a:latin typeface="Calibri"/>
-                <a:cs typeface="Calibri"/>
-              </a:rPr>
-              <a:t>STREAMLIT.</a:t>
-            </a:r>
-            <a:r>
-              <a:rPr lang="pt-BR" sz="1300" i="1" spc="-10" dirty="0">
-                <a:solidFill>
-                  <a:srgbClr val="191919"/>
-                </a:solidFill>
-                <a:latin typeface="Calibri"/>
-                <a:cs typeface="Calibri"/>
-              </a:rPr>
-              <a:t> </a:t>
-            </a:r>
-            <a:r>
-              <a:rPr lang="pt-BR" sz="1300" i="1" spc="-10" dirty="0" err="1">
-                <a:solidFill>
-                  <a:srgbClr val="191919"/>
-                </a:solidFill>
-                <a:latin typeface="Calibri"/>
-                <a:cs typeface="Calibri"/>
-              </a:rPr>
-              <a:t>Streamlit</a:t>
-            </a:r>
-            <a:r>
-              <a:rPr lang="pt-BR" sz="1300" i="1" spc="-10" dirty="0">
-                <a:solidFill>
-                  <a:srgbClr val="191919"/>
-                </a:solidFill>
-                <a:latin typeface="Calibri"/>
-                <a:cs typeface="Calibri"/>
-              </a:rPr>
-              <a:t> </a:t>
-            </a:r>
-            <a:r>
-              <a:rPr lang="pt-BR" sz="1300" i="1" spc="-10" dirty="0" err="1">
-                <a:solidFill>
-                  <a:srgbClr val="191919"/>
-                </a:solidFill>
-                <a:latin typeface="Calibri"/>
-                <a:cs typeface="Calibri"/>
-              </a:rPr>
-              <a:t>documentation</a:t>
-            </a:r>
-            <a:r>
-              <a:rPr lang="pt-BR" sz="1300" i="1" spc="-10" dirty="0">
-                <a:solidFill>
-                  <a:srgbClr val="191919"/>
-                </a:solidFill>
-                <a:latin typeface="Calibri"/>
-                <a:cs typeface="Calibri"/>
-              </a:rPr>
-              <a:t>. Disponível em: https://docs.streamlit.io/. Acesso em: 2026. </a:t>
-            </a:r>
-          </a:p>
-          <a:p>
-            <a:pPr marL="12700" marR="5080">
-              <a:lnSpc>
-                <a:spcPct val="238800"/>
-              </a:lnSpc>
-            </a:pPr>
-            <a:r>
-              <a:rPr lang="pt-BR" sz="1300" b="1" i="1" spc="-10" dirty="0">
-                <a:solidFill>
-                  <a:srgbClr val="191919"/>
-                </a:solidFill>
-                <a:latin typeface="Calibri"/>
-                <a:cs typeface="Calibri"/>
-              </a:rPr>
-              <a:t>FATEC OURINHOS. </a:t>
-            </a:r>
-            <a:r>
-              <a:rPr lang="pt-BR" sz="1300" i="1" spc="-10" dirty="0">
-                <a:solidFill>
-                  <a:srgbClr val="191919"/>
-                </a:solidFill>
-                <a:latin typeface="Calibri"/>
-                <a:cs typeface="Calibri"/>
-              </a:rPr>
-              <a:t>Trabalho Final: Agente de Analise Exploratória de Dados em Linguagem Natural. Material da disciplina de Processamento de Linguagem Natural, 2026.</a:t>
-            </a:r>
-          </a:p>
-          <a:p>
-            <a:pPr marL="12700" marR="5080">
-              <a:lnSpc>
-                <a:spcPct val="238800"/>
-              </a:lnSpc>
-            </a:pPr>
-            <a:endParaRPr sz="1300" dirty="0">
-              <a:latin typeface="Calibri"/>
-              <a:cs typeface="Calibri"/>
+              <a:rPr lang="pt-BR" sz="1100" b="1" i="1" dirty="0">
+                <a:latin typeface="+mj-lt"/>
+                <a:ea typeface="Calibri" panose="020F0502020204030204" pitchFamily="34" charset="0"/>
+                <a:cs typeface="Calibri" panose="020F0502020204030204" pitchFamily="34" charset="0"/>
+              </a:rPr>
+              <a:t>DEEPSEEK</a:t>
+            </a:r>
+            <a:r>
+              <a:rPr lang="pt-BR" sz="1100" i="1" dirty="0">
+                <a:latin typeface="+mj-lt"/>
+                <a:ea typeface="Calibri" panose="020F0502020204030204" pitchFamily="34" charset="0"/>
+                <a:cs typeface="Calibri" panose="020F0502020204030204" pitchFamily="34" charset="0"/>
+              </a:rPr>
+              <a:t>.. Disponível em: </a:t>
+            </a:r>
+            <a:r>
+              <a:rPr lang="pt-BR" sz="1100" i="1" dirty="0">
+                <a:latin typeface="+mj-lt"/>
+                <a:ea typeface="Calibri" panose="020F0502020204030204" pitchFamily="34" charset="0"/>
+                <a:cs typeface="Calibri" panose="020F0502020204030204" pitchFamily="34" charset="0"/>
+                <a:hlinkClick r:id="rId2"/>
+              </a:rPr>
+              <a:t>https://api</a:t>
+            </a:r>
+            <a:r>
+              <a:rPr lang="pt-BR" sz="1100" i="1" dirty="0">
+                <a:latin typeface="+mj-lt"/>
+                <a:ea typeface="Calibri" panose="020F0502020204030204" pitchFamily="34" charset="0"/>
+                <a:cs typeface="Calibri" panose="020F0502020204030204" pitchFamily="34" charset="0"/>
+                <a:hlinkClick r:id="rId3"/>
+              </a:rPr>
+              <a:t>-docs.deepseek.com/</a:t>
+            </a:r>
+            <a:r>
+              <a:rPr lang="pt-BR" sz="1100" i="1" dirty="0" err="1">
+                <a:latin typeface="+mj-lt"/>
+                <a:ea typeface="Calibri" panose="020F0502020204030204" pitchFamily="34" charset="0"/>
+                <a:cs typeface="Calibri" panose="020F0502020204030204" pitchFamily="34" charset="0"/>
+                <a:hlinkClick r:id="rId3"/>
+              </a:rPr>
+              <a:t>news</a:t>
+            </a:r>
+            <a:r>
+              <a:rPr lang="pt-BR" sz="1100" i="1" dirty="0">
+                <a:latin typeface="+mj-lt"/>
+                <a:ea typeface="Calibri" panose="020F0502020204030204" pitchFamily="34" charset="0"/>
+                <a:cs typeface="Calibri" panose="020F0502020204030204" pitchFamily="34" charset="0"/>
+                <a:hlinkClick r:id="rId3"/>
+              </a:rPr>
+              <a:t>/news0802</a:t>
+            </a:r>
+            <a:r>
+              <a:rPr lang="pt-BR" sz="1100" i="1" dirty="0">
+                <a:latin typeface="+mj-lt"/>
+                <a:ea typeface="Calibri" panose="020F0502020204030204" pitchFamily="34" charset="0"/>
+                <a:cs typeface="Calibri" panose="020F0502020204030204" pitchFamily="34" charset="0"/>
+              </a:rPr>
+              <a:t>. </a:t>
+            </a:r>
+            <a:r>
+              <a:rPr lang="pt-BR" sz="1100" i="1" dirty="0" err="1">
+                <a:latin typeface="+mj-lt"/>
+                <a:ea typeface="Calibri" panose="020F0502020204030204" pitchFamily="34" charset="0"/>
+                <a:cs typeface="Calibri" panose="020F0502020204030204" pitchFamily="34" charset="0"/>
+              </a:rPr>
+              <a:t>DeepSeek</a:t>
+            </a:r>
+            <a:r>
+              <a:rPr lang="pt-BR" sz="1100" i="1" dirty="0">
+                <a:latin typeface="+mj-lt"/>
+                <a:ea typeface="Calibri" panose="020F0502020204030204" pitchFamily="34" charset="0"/>
+                <a:cs typeface="Calibri" panose="020F0502020204030204" pitchFamily="34" charset="0"/>
+              </a:rPr>
+              <a:t> API </a:t>
+            </a:r>
+            <a:r>
+              <a:rPr lang="pt-BR" sz="1100" i="1" dirty="0" err="1">
+                <a:latin typeface="+mj-lt"/>
+                <a:ea typeface="Calibri" panose="020F0502020204030204" pitchFamily="34" charset="0"/>
+                <a:cs typeface="Calibri" panose="020F0502020204030204" pitchFamily="34" charset="0"/>
+              </a:rPr>
+              <a:t>introduces</a:t>
+            </a:r>
+            <a:r>
+              <a:rPr lang="pt-BR" sz="1100" i="1" dirty="0">
+                <a:latin typeface="+mj-lt"/>
+                <a:ea typeface="Calibri" panose="020F0502020204030204" pitchFamily="34" charset="0"/>
+                <a:cs typeface="Calibri" panose="020F0502020204030204" pitchFamily="34" charset="0"/>
+              </a:rPr>
+              <a:t> </a:t>
+            </a:r>
+            <a:r>
+              <a:rPr lang="pt-BR" sz="1100" i="1" dirty="0" err="1">
+                <a:latin typeface="+mj-lt"/>
+                <a:ea typeface="Calibri" panose="020F0502020204030204" pitchFamily="34" charset="0"/>
+                <a:cs typeface="Calibri" panose="020F0502020204030204" pitchFamily="34" charset="0"/>
+              </a:rPr>
+              <a:t>Context</a:t>
+            </a:r>
+            <a:r>
+              <a:rPr lang="pt-BR" sz="1100" i="1" dirty="0">
+                <a:latin typeface="+mj-lt"/>
+                <a:ea typeface="Calibri" panose="020F0502020204030204" pitchFamily="34" charset="0"/>
+                <a:cs typeface="Calibri" panose="020F0502020204030204" pitchFamily="34" charset="0"/>
+              </a:rPr>
+              <a:t> </a:t>
+            </a:r>
+            <a:r>
+              <a:rPr lang="pt-BR" sz="1100" i="1" dirty="0" err="1">
+                <a:latin typeface="+mj-lt"/>
+                <a:ea typeface="Calibri" panose="020F0502020204030204" pitchFamily="34" charset="0"/>
+                <a:cs typeface="Calibri" panose="020F0502020204030204" pitchFamily="34" charset="0"/>
+              </a:rPr>
+              <a:t>Caching</a:t>
+            </a:r>
+            <a:r>
+              <a:rPr lang="pt-BR" sz="1100" i="1" dirty="0">
+                <a:latin typeface="+mj-lt"/>
+                <a:ea typeface="Calibri" panose="020F0502020204030204" pitchFamily="34" charset="0"/>
+                <a:cs typeface="Calibri" panose="020F0502020204030204" pitchFamily="34" charset="0"/>
+              </a:rPr>
+              <a:t> </a:t>
+            </a:r>
+            <a:r>
+              <a:rPr lang="pt-BR" sz="1100" i="1" dirty="0" err="1">
+                <a:latin typeface="+mj-lt"/>
+                <a:ea typeface="Calibri" panose="020F0502020204030204" pitchFamily="34" charset="0"/>
+                <a:cs typeface="Calibri" panose="020F0502020204030204" pitchFamily="34" charset="0"/>
+              </a:rPr>
+              <a:t>on</a:t>
+            </a:r>
+            <a:r>
+              <a:rPr lang="pt-BR" sz="1100" i="1" dirty="0">
+                <a:latin typeface="+mj-lt"/>
+                <a:ea typeface="Calibri" panose="020F0502020204030204" pitchFamily="34" charset="0"/>
+                <a:cs typeface="Calibri" panose="020F0502020204030204" pitchFamily="34" charset="0"/>
+              </a:rPr>
+              <a:t> Disk, </a:t>
+            </a:r>
+            <a:r>
+              <a:rPr lang="pt-BR" sz="1100" i="1" dirty="0" err="1">
+                <a:latin typeface="+mj-lt"/>
+                <a:ea typeface="Calibri" panose="020F0502020204030204" pitchFamily="34" charset="0"/>
+                <a:cs typeface="Calibri" panose="020F0502020204030204" pitchFamily="34" charset="0"/>
+              </a:rPr>
+              <a:t>cutting</a:t>
+            </a:r>
+            <a:r>
+              <a:rPr lang="pt-BR" sz="1100" i="1" dirty="0">
+                <a:latin typeface="+mj-lt"/>
+                <a:ea typeface="Calibri" panose="020F0502020204030204" pitchFamily="34" charset="0"/>
+                <a:cs typeface="Calibri" panose="020F0502020204030204" pitchFamily="34" charset="0"/>
+              </a:rPr>
+              <a:t> </a:t>
+            </a:r>
+            <a:r>
+              <a:rPr lang="pt-BR" sz="1100" i="1" dirty="0" err="1">
+                <a:latin typeface="+mj-lt"/>
+                <a:ea typeface="Calibri" panose="020F0502020204030204" pitchFamily="34" charset="0"/>
+                <a:cs typeface="Calibri" panose="020F0502020204030204" pitchFamily="34" charset="0"/>
+              </a:rPr>
+              <a:t>prices</a:t>
+            </a:r>
+            <a:r>
+              <a:rPr lang="pt-BR" sz="1100" i="1" dirty="0">
+                <a:latin typeface="+mj-lt"/>
+                <a:ea typeface="Calibri" panose="020F0502020204030204" pitchFamily="34" charset="0"/>
+                <a:cs typeface="Calibri" panose="020F0502020204030204" pitchFamily="34" charset="0"/>
+              </a:rPr>
+              <a:t> </a:t>
+            </a:r>
+            <a:r>
+              <a:rPr lang="pt-BR" sz="1100" i="1" dirty="0" err="1">
+                <a:latin typeface="+mj-lt"/>
+                <a:ea typeface="Calibri" panose="020F0502020204030204" pitchFamily="34" charset="0"/>
+                <a:cs typeface="Calibri" panose="020F0502020204030204" pitchFamily="34" charset="0"/>
+              </a:rPr>
+              <a:t>by</a:t>
+            </a:r>
+            <a:r>
+              <a:rPr lang="pt-BR" sz="1100" i="1" dirty="0">
+                <a:latin typeface="+mj-lt"/>
+                <a:ea typeface="Calibri" panose="020F0502020204030204" pitchFamily="34" charset="0"/>
+                <a:cs typeface="Calibri" panose="020F0502020204030204" pitchFamily="34" charset="0"/>
+              </a:rPr>
+              <a:t> </a:t>
+            </a:r>
+            <a:r>
+              <a:rPr lang="pt-BR" sz="1100" i="1" dirty="0" err="1">
+                <a:latin typeface="+mj-lt"/>
+                <a:ea typeface="Calibri" panose="020F0502020204030204" pitchFamily="34" charset="0"/>
+                <a:cs typeface="Calibri" panose="020F0502020204030204" pitchFamily="34" charset="0"/>
+              </a:rPr>
+              <a:t>an</a:t>
+            </a:r>
+            <a:r>
+              <a:rPr lang="pt-BR" sz="1100" i="1" dirty="0">
+                <a:latin typeface="+mj-lt"/>
+                <a:ea typeface="Calibri" panose="020F0502020204030204" pitchFamily="34" charset="0"/>
+                <a:cs typeface="Calibri" panose="020F0502020204030204" pitchFamily="34" charset="0"/>
+              </a:rPr>
+              <a:t> </a:t>
+            </a:r>
+            <a:r>
+              <a:rPr lang="pt-BR" sz="1100" i="1" dirty="0" err="1">
+                <a:latin typeface="+mj-lt"/>
+                <a:ea typeface="Calibri" panose="020F0502020204030204" pitchFamily="34" charset="0"/>
+                <a:cs typeface="Calibri" panose="020F0502020204030204" pitchFamily="34" charset="0"/>
+              </a:rPr>
+              <a:t>order</a:t>
+            </a:r>
+            <a:r>
+              <a:rPr lang="pt-BR" sz="1100" i="1" dirty="0">
+                <a:latin typeface="+mj-lt"/>
+                <a:ea typeface="Calibri" panose="020F0502020204030204" pitchFamily="34" charset="0"/>
+                <a:cs typeface="Calibri" panose="020F0502020204030204" pitchFamily="34" charset="0"/>
+              </a:rPr>
+              <a:t> of magnitude. </a:t>
+            </a:r>
+            <a:r>
+              <a:rPr lang="pt-BR" sz="1100" i="1" dirty="0">
+                <a:ea typeface="Calibri" panose="020F0502020204030204" pitchFamily="34" charset="0"/>
+                <a:cs typeface="Calibri" panose="020F0502020204030204" pitchFamily="34" charset="0"/>
+              </a:rPr>
+              <a:t>Acesso em: 9 jun. 2026</a:t>
+            </a:r>
+            <a:endParaRPr lang="pt-BR" sz="1100" i="1" dirty="0">
+              <a:latin typeface="+mj-lt"/>
+              <a:ea typeface="Calibri" panose="020F0502020204030204" pitchFamily="34" charset="0"/>
+              <a:cs typeface="Calibri" panose="020F0502020204030204" pitchFamily="34" charset="0"/>
             </a:endParaRPr>
           </a:p>
           <a:p>
@@ -9405,71 +11126,11 @@
                 <a:spcPct val="100000"/>
               </a:lnSpc>
             </a:pPr>
-            <a:r>
-              <a:rPr sz="1300" b="1" spc="-10" dirty="0">
-                <a:solidFill>
-                  <a:srgbClr val="191919"/>
-                </a:solidFill>
-                <a:latin typeface="Calibri"/>
-                <a:cs typeface="Calibri"/>
-              </a:rPr>
-              <a:t>Repositório</a:t>
-            </a:r>
-            <a:r>
-              <a:rPr sz="1300" b="1" spc="-25" dirty="0">
-                <a:solidFill>
-                  <a:srgbClr val="191919"/>
-                </a:solidFill>
-                <a:latin typeface="Calibri"/>
-                <a:cs typeface="Calibri"/>
-              </a:rPr>
-              <a:t> </a:t>
-            </a:r>
-            <a:r>
-              <a:rPr sz="1300" b="1" dirty="0">
-                <a:solidFill>
-                  <a:srgbClr val="191919"/>
-                </a:solidFill>
-                <a:latin typeface="Calibri"/>
-                <a:cs typeface="Calibri"/>
-              </a:rPr>
-              <a:t>do</a:t>
-            </a:r>
-            <a:r>
-              <a:rPr sz="1300" b="1" spc="-30" dirty="0">
-                <a:solidFill>
-                  <a:srgbClr val="191919"/>
-                </a:solidFill>
-                <a:latin typeface="Calibri"/>
-                <a:cs typeface="Calibri"/>
-              </a:rPr>
-              <a:t> </a:t>
-            </a:r>
-            <a:r>
-              <a:rPr sz="1300" b="1" spc="-10" dirty="0" err="1">
-                <a:solidFill>
-                  <a:srgbClr val="191919"/>
-                </a:solidFill>
-                <a:latin typeface="Calibri"/>
-                <a:cs typeface="Calibri"/>
-              </a:rPr>
-              <a:t>projeto</a:t>
-            </a:r>
-            <a:r>
-              <a:rPr sz="1300" b="1" spc="-10" dirty="0">
-                <a:solidFill>
-                  <a:srgbClr val="191919"/>
-                </a:solidFill>
-                <a:latin typeface="Calibri"/>
-                <a:cs typeface="Calibri"/>
-              </a:rPr>
-              <a:t>:</a:t>
-            </a:r>
-            <a:endParaRPr lang="pt-BR" sz="1300" b="1" spc="-10" dirty="0">
+            <a:endParaRPr lang="pt-BR" sz="1100" b="1" spc="-10" dirty="0">
               <a:solidFill>
                 <a:srgbClr val="191919"/>
               </a:solidFill>
-              <a:latin typeface="Calibri"/>
+              <a:latin typeface="+mj-lt"/>
               <a:cs typeface="Calibri"/>
             </a:endParaRPr>
           </a:p>
@@ -9479,33 +11140,301 @@
                 <a:spcPct val="100000"/>
               </a:lnSpc>
             </a:pPr>
-            <a:r>
-              <a:rPr lang="pt-BR" sz="1400" spc="-10" dirty="0">
-                <a:solidFill>
-                  <a:schemeClr val="tx1"/>
-                </a:solidFill>
-                <a:latin typeface="+mj-lt"/>
-                <a:cs typeface="Courier New"/>
-              </a:rPr>
-              <a:t>https://github.com/rmansano/projeto_agente_eda/tree/main</a:t>
-            </a:r>
-            <a:r>
-              <a:rPr sz="1300" i="1" spc="-10" dirty="0">
-                <a:solidFill>
-                  <a:schemeClr val="tx1"/>
-                </a:solidFill>
-                <a:latin typeface="+mj-lt"/>
-                <a:cs typeface="Calibri"/>
-              </a:rPr>
-              <a:t>]</a:t>
-            </a:r>
-            <a:endParaRPr sz="1300" dirty="0">
+            <a:endParaRPr lang="pt-BR" sz="1100" b="1" spc="-10" dirty="0">
               <a:solidFill>
-                <a:schemeClr val="tx1"/>
+                <a:srgbClr val="191919"/>
               </a:solidFill>
               <a:latin typeface="+mj-lt"/>
               <a:cs typeface="Calibri"/>
             </a:endParaRPr>
+          </a:p>
+          <a:p>
+            <a:pPr marL="12700">
+              <a:lnSpc>
+                <a:spcPct val="100000"/>
+              </a:lnSpc>
+            </a:pPr>
+            <a:endParaRPr lang="pt-BR" sz="1100" b="1" spc="-10" dirty="0">
+              <a:solidFill>
+                <a:srgbClr val="191919"/>
+              </a:solidFill>
+              <a:latin typeface="+mj-lt"/>
+              <a:cs typeface="Calibri"/>
+            </a:endParaRPr>
+          </a:p>
+          <a:p>
+            <a:pPr marL="12700">
+              <a:lnSpc>
+                <a:spcPct val="100000"/>
+              </a:lnSpc>
+            </a:pPr>
+            <a:endParaRPr lang="pt-BR" sz="1100" b="1" spc="-10" dirty="0">
+              <a:solidFill>
+                <a:srgbClr val="191919"/>
+              </a:solidFill>
+              <a:latin typeface="+mj-lt"/>
+              <a:cs typeface="Calibri"/>
+            </a:endParaRPr>
+          </a:p>
+          <a:p>
+            <a:pPr marL="12700">
+              <a:lnSpc>
+                <a:spcPct val="100000"/>
+              </a:lnSpc>
+            </a:pPr>
+            <a:endParaRPr lang="pt-BR" sz="1100" b="1" spc="-10" dirty="0">
+              <a:solidFill>
+                <a:srgbClr val="191919"/>
+              </a:solidFill>
+              <a:latin typeface="+mj-lt"/>
+              <a:cs typeface="Calibri"/>
+            </a:endParaRPr>
+          </a:p>
+          <a:p>
+            <a:pPr marL="12700">
+              <a:lnSpc>
+                <a:spcPct val="100000"/>
+              </a:lnSpc>
+            </a:pPr>
+            <a:endParaRPr lang="pt-BR" sz="1100" b="1" spc="-10" dirty="0">
+              <a:solidFill>
+                <a:srgbClr val="191919"/>
+              </a:solidFill>
+              <a:latin typeface="+mj-lt"/>
+              <a:cs typeface="Calibri"/>
+            </a:endParaRPr>
+          </a:p>
+          <a:p>
+            <a:pPr marL="12700">
+              <a:lnSpc>
+                <a:spcPct val="100000"/>
+              </a:lnSpc>
+            </a:pPr>
+            <a:endParaRPr lang="pt-BR" sz="1100" b="1" spc="-10" dirty="0">
+              <a:solidFill>
+                <a:srgbClr val="191919"/>
+              </a:solidFill>
+              <a:latin typeface="+mj-lt"/>
+              <a:cs typeface="Calibri"/>
+            </a:endParaRPr>
+          </a:p>
+          <a:p>
+            <a:pPr marL="12700">
+              <a:lnSpc>
+                <a:spcPct val="100000"/>
+              </a:lnSpc>
+            </a:pPr>
+            <a:endParaRPr lang="pt-BR" sz="1100" b="1" spc="-10" dirty="0">
+              <a:solidFill>
+                <a:srgbClr val="191919"/>
+              </a:solidFill>
+              <a:latin typeface="+mj-lt"/>
+              <a:cs typeface="Calibri"/>
+            </a:endParaRPr>
+          </a:p>
+          <a:p>
+            <a:pPr marL="12700">
+              <a:lnSpc>
+                <a:spcPct val="100000"/>
+              </a:lnSpc>
+            </a:pPr>
+            <a:endParaRPr lang="pt-BR" sz="1100" b="1" spc="-10" dirty="0">
+              <a:solidFill>
+                <a:srgbClr val="191919"/>
+              </a:solidFill>
+              <a:latin typeface="+mj-lt"/>
+              <a:cs typeface="Calibri"/>
+            </a:endParaRPr>
+          </a:p>
+          <a:p>
+            <a:pPr marL="12700">
+              <a:lnSpc>
+                <a:spcPct val="100000"/>
+              </a:lnSpc>
+            </a:pPr>
+            <a:endParaRPr lang="pt-BR" sz="1100" b="1" spc="-10" dirty="0">
+              <a:solidFill>
+                <a:srgbClr val="191919"/>
+              </a:solidFill>
+              <a:latin typeface="+mj-lt"/>
+              <a:cs typeface="Calibri"/>
+            </a:endParaRPr>
+          </a:p>
+          <a:p>
+            <a:pPr marL="12700">
+              <a:lnSpc>
+                <a:spcPct val="100000"/>
+              </a:lnSpc>
+            </a:pPr>
+            <a:endParaRPr lang="pt-BR" sz="1100" b="1" spc="-10" dirty="0">
+              <a:solidFill>
+                <a:srgbClr val="191919"/>
+              </a:solidFill>
+              <a:latin typeface="+mj-lt"/>
+              <a:cs typeface="Calibri"/>
+            </a:endParaRPr>
+          </a:p>
+          <a:p>
+            <a:pPr marL="12700">
+              <a:lnSpc>
+                <a:spcPct val="100000"/>
+              </a:lnSpc>
+            </a:pPr>
+            <a:endParaRPr lang="pt-BR" sz="1100" b="1" spc="-10" dirty="0">
+              <a:solidFill>
+                <a:srgbClr val="191919"/>
+              </a:solidFill>
+              <a:latin typeface="+mj-lt"/>
+              <a:cs typeface="Calibri"/>
+            </a:endParaRPr>
+          </a:p>
+          <a:p>
+            <a:pPr marL="12700">
+              <a:lnSpc>
+                <a:spcPct val="100000"/>
+              </a:lnSpc>
+            </a:pPr>
+            <a:endParaRPr lang="pt-BR" sz="1100" b="1" spc="-10" dirty="0">
+              <a:solidFill>
+                <a:srgbClr val="191919"/>
+              </a:solidFill>
+              <a:latin typeface="+mj-lt"/>
+              <a:cs typeface="Calibri"/>
+            </a:endParaRPr>
+          </a:p>
+          <a:p>
+            <a:pPr marL="12700">
+              <a:lnSpc>
+                <a:spcPct val="100000"/>
+              </a:lnSpc>
+            </a:pPr>
+            <a:r>
+              <a:rPr lang="pt-BR" sz="1100" b="1" spc="-10" dirty="0">
+                <a:solidFill>
+                  <a:srgbClr val="191919"/>
+                </a:solidFill>
+                <a:latin typeface="+mj-lt"/>
+                <a:cs typeface="Calibri"/>
+              </a:rPr>
+              <a:t>Repositório</a:t>
+            </a:r>
+            <a:r>
+              <a:rPr lang="pt-BR" sz="1100" b="1" spc="-25" dirty="0">
+                <a:solidFill>
+                  <a:srgbClr val="191919"/>
+                </a:solidFill>
+                <a:latin typeface="+mj-lt"/>
+                <a:cs typeface="Calibri"/>
+              </a:rPr>
+              <a:t> </a:t>
+            </a:r>
+            <a:r>
+              <a:rPr lang="pt-BR" sz="1100" b="1" dirty="0">
+                <a:solidFill>
+                  <a:srgbClr val="191919"/>
+                </a:solidFill>
+                <a:latin typeface="+mj-lt"/>
+                <a:cs typeface="Calibri"/>
+              </a:rPr>
+              <a:t>do</a:t>
+            </a:r>
+            <a:r>
+              <a:rPr lang="pt-BR" sz="1100" b="1" spc="-30" dirty="0">
+                <a:solidFill>
+                  <a:srgbClr val="191919"/>
+                </a:solidFill>
+                <a:latin typeface="+mj-lt"/>
+                <a:cs typeface="Calibri"/>
+              </a:rPr>
+              <a:t> </a:t>
+            </a:r>
+            <a:r>
+              <a:rPr lang="pt-BR" sz="1100" b="1" spc="-10" dirty="0">
+                <a:solidFill>
+                  <a:srgbClr val="191919"/>
+                </a:solidFill>
+                <a:latin typeface="+mj-lt"/>
+                <a:cs typeface="Calibri"/>
+              </a:rPr>
+              <a:t>projeto:</a:t>
+            </a:r>
+          </a:p>
+          <a:p>
+            <a:pPr marL="12700">
+              <a:lnSpc>
+                <a:spcPct val="100000"/>
+              </a:lnSpc>
+            </a:pPr>
+            <a:r>
+              <a:rPr lang="pt-BR" sz="1100" spc="-10" dirty="0">
+                <a:latin typeface="+mj-lt"/>
+                <a:cs typeface="Courier New"/>
+              </a:rPr>
+              <a:t>https://github.com/</a:t>
+            </a:r>
+            <a:r>
+              <a:rPr lang="pt-BR" sz="1100" spc="-10" dirty="0" err="1">
+                <a:latin typeface="+mj-lt"/>
+                <a:cs typeface="Courier New"/>
+              </a:rPr>
+              <a:t>rmansano</a:t>
+            </a:r>
+            <a:r>
+              <a:rPr lang="pt-BR" sz="1100" spc="-10" dirty="0">
+                <a:latin typeface="+mj-lt"/>
+                <a:cs typeface="Courier New"/>
+              </a:rPr>
+              <a:t>/</a:t>
+            </a:r>
+            <a:r>
+              <a:rPr lang="pt-BR" sz="1100" spc="-10" dirty="0" err="1">
+                <a:latin typeface="+mj-lt"/>
+                <a:cs typeface="Courier New"/>
+              </a:rPr>
+              <a:t>projeto_agente_eda</a:t>
+            </a:r>
+            <a:r>
+              <a:rPr lang="pt-BR" sz="1100" spc="-10" dirty="0">
+                <a:latin typeface="+mj-lt"/>
+                <a:cs typeface="Courier New"/>
+              </a:rPr>
+              <a:t>/</a:t>
+            </a:r>
+            <a:r>
+              <a:rPr lang="pt-BR" sz="1100" spc="-10" dirty="0" err="1">
+                <a:latin typeface="+mj-lt"/>
+                <a:cs typeface="Courier New"/>
+              </a:rPr>
+              <a:t>tree</a:t>
+            </a:r>
+            <a:r>
+              <a:rPr lang="pt-BR" sz="1100" spc="-10" dirty="0">
+                <a:latin typeface="+mj-lt"/>
+                <a:cs typeface="Courier New"/>
+              </a:rPr>
+              <a:t>/</a:t>
+            </a:r>
+            <a:r>
+              <a:rPr lang="pt-BR" sz="1100" spc="-10" dirty="0" err="1">
+                <a:latin typeface="+mj-lt"/>
+                <a:cs typeface="Courier New"/>
+              </a:rPr>
+              <a:t>main</a:t>
+            </a:r>
+            <a:r>
+              <a:rPr lang="pt-BR" sz="1100" i="1" spc="-10" dirty="0">
+                <a:latin typeface="+mj-lt"/>
+                <a:cs typeface="Calibri"/>
+              </a:rPr>
+              <a:t>]</a:t>
+            </a:r>
+            <a:endParaRPr lang="pt-BR" sz="1100" dirty="0">
+              <a:latin typeface="+mj-lt"/>
+              <a:cs typeface="Calibri"/>
+            </a:endParaRPr>
+          </a:p>
+          <a:p>
+            <a:endParaRPr lang="pt-BR" dirty="0"/>
           </a:p>
         </p:txBody>
       </p:sp>
@@ -9680,7 +11609,7 @@
             </a:pPr>
             <a:fld id="{81D60167-4931-47E6-BA6A-407CBD079E47}" type="slidenum">
               <a:rPr dirty="0"/>
-              <a:t>18</a:t>
+              <a:t>20</a:t>
             </a:fld>
             <a:r>
               <a:rPr spc="-15" dirty="0"/>
@@ -9695,9 +11624,52 @@
               <a:t> </a:t>
             </a:r>
             <a:r>
-              <a:rPr spc="-25" dirty="0"/>
-              <a:t>14</a:t>
-            </a:r>
+              <a:rPr lang="pt-BR" spc="-25" dirty="0"/>
+              <a:t>18</a:t>
+            </a:r>
+            <a:endParaRPr spc="-25" dirty="0"/>
+          </a:p>
+        </p:txBody>
+      </p:sp>
+      <p:sp>
+        <p:nvSpPr>
+          <p:cNvPr id="3" name="object 3"/>
+          <p:cNvSpPr/>
+          <p:nvPr/>
+        </p:nvSpPr>
+        <p:spPr>
+          <a:xfrm>
+            <a:off x="457200" y="6400800"/>
+            <a:ext cx="11247120" cy="635"/>
+          </a:xfrm>
+          <a:custGeom>
+            <a:avLst/>
+            <a:gdLst/>
+            <a:ahLst/>
+            <a:cxnLst/>
+            <a:rect l="l" t="t" r="r" b="b"/>
+            <a:pathLst>
+              <a:path w="11247120" h="635">
+                <a:moveTo>
+                  <a:pt x="0" y="0"/>
+                </a:moveTo>
+                <a:lnTo>
+                  <a:pt x="11247120" y="355"/>
+                </a:lnTo>
+              </a:path>
+            </a:pathLst>
+          </a:custGeom>
+          <a:ln w="6479">
+            <a:solidFill>
+              <a:srgbClr val="C7C7C7"/>
+            </a:solidFill>
+          </a:ln>
+        </p:spPr>
+        <p:txBody>
+          <a:bodyPr wrap="square" lIns="0" tIns="0" rIns="0" bIns="0" rtlCol="0"/>
+          <a:lstStyle/>
+          <a:p>
+            <a:endParaRPr/>
           </a:p>
         </p:txBody>
       </p:sp>
@@ -9709,7 +11681,7 @@
 </p:sld>
 </file>
 
-<file path=ppt/slides/slide19.xml><?xml version="1.0" encoding="utf-8"?>
+<file path=ppt/slides/slide21.xml><?xml version="1.0" encoding="utf-8"?>
 <p:sld xmlns:a="http://schemas.openxmlformats.org/drawingml/2006/main" xmlns:r="http://schemas.openxmlformats.org/officeDocument/2006/relationships" xmlns:p="http://schemas.openxmlformats.org/presentationml/2006/main" showMasterSp="0">
   <p:cSld>
     <p:spTree>
@@ -10050,8 +12022,8 @@
         </p:nvSpPr>
         <p:spPr>
           <a:xfrm>
-            <a:off x="2422759" y="5570637"/>
-            <a:ext cx="7635660" cy="259045"/>
+            <a:off x="3611679" y="5570637"/>
+            <a:ext cx="4968641" cy="259045"/>
           </a:xfrm>
           <a:prstGeom prst="rect">
             <a:avLst/>
@@ -10098,35 +12070,6 @@
                 </a:solidFill>
                 <a:latin typeface="+mj-lt"/>
               </a:rPr>
-              <a:t>André Barbosa Alves dos Santos</a:t>
-            </a:r>
-            <a:r>
-              <a:rPr sz="1600" i="1" dirty="0">
-                <a:solidFill>
-                  <a:schemeClr val="bg1"/>
-                </a:solidFill>
-                <a:latin typeface="+mj-lt"/>
-                <a:cs typeface="Calibri"/>
-              </a:rPr>
-              <a:t>|</a:t>
-            </a:r>
-            <a:r>
-              <a:rPr sz="1600" i="1" spc="-20" dirty="0">
-                <a:solidFill>
-                  <a:schemeClr val="bg1"/>
-                </a:solidFill>
-                <a:latin typeface="+mj-lt"/>
-                <a:cs typeface="Calibri"/>
-              </a:rPr>
-              <a:t> </a:t>
-            </a:r>
-            <a:r>
-              <a:rPr lang="pt-BR" sz="1600" i="1" dirty="0">
-                <a:solidFill>
-                  <a:schemeClr val="bg1"/>
-                </a:solidFill>
-                <a:latin typeface="+mj-lt"/>
-              </a:rPr>
               <a:t>Rafael Marques Mansano</a:t>
             </a:r>
             <a:r>
@@ -10165,1401 +12108,6 @@
               <a:latin typeface="+mj-lt"/>
               <a:cs typeface="Calibri"/>
             </a:endParaRPr>
-          </a:p>
-        </p:txBody>
-      </p:sp>
-    </p:spTree>
-  </p:cSld>
-  <p:clrMapOvr>
-    <a:masterClrMapping/>
-  </p:clrMapOvr>
-</p:sld>
-</file>
-
-<file path=ppt/slides/slide2.xml><?xml version="1.0" encoding="utf-8"?>
-<p:sld xmlns:a="http://schemas.openxmlformats.org/drawingml/2006/main" xmlns:r="http://schemas.openxmlformats.org/officeDocument/2006/relationships" xmlns:p="http://schemas.openxmlformats.org/presentationml/2006/main">
-  <p:cSld>
-    <p:spTree>
-      <p:nvGrpSpPr>
-        <p:cNvPr id="1" name=""/>
-        <p:cNvGrpSpPr/>
-        <p:nvPr/>
-      </p:nvGrpSpPr>
-      <p:grpSpPr>
-        <a:xfrm>
-          <a:off x="0" y="0"/>
-          <a:ext cx="0" cy="0"/>
-          <a:chOff x="0" y="0"/>
-          <a:chExt cx="0" cy="0"/>
-        </a:xfrm>
-      </p:grpSpPr>
-      <p:sp>
-        <p:nvSpPr>
-          <p:cNvPr id="2" name="object 2" descr="$PPTXTitle"/>
-          <p:cNvSpPr txBox="1">
-            <a:spLocks noGrp="1"/>
-          </p:cNvSpPr>
-          <p:nvPr>
-            <p:ph type="title"/>
-          </p:nvPr>
-        </p:nvSpPr>
-        <p:spPr>
-          <a:prstGeom prst="rect">
-            <a:avLst/>
-          </a:prstGeom>
-        </p:spPr>
-        <p:txBody>
-          <a:bodyPr vert="horz" wrap="square" lIns="0" tIns="12700" rIns="0" bIns="0" rtlCol="0">
-            <a:spAutoFit/>
-          </a:bodyPr>
-          <a:lstStyle/>
-          <a:p>
-            <a:pPr marL="12700">
-              <a:lnSpc>
-                <a:spcPct val="100000"/>
-              </a:lnSpc>
-              <a:spcBef>
-                <a:spcPts val="100"/>
-              </a:spcBef>
-            </a:pPr>
-            <a:r>
-              <a:rPr spc="-10" dirty="0"/>
-              <a:t>Agenda</a:t>
-            </a:r>
-          </a:p>
-        </p:txBody>
-      </p:sp>
-      <p:sp>
-        <p:nvSpPr>
-          <p:cNvPr id="3" name="object 3"/>
-          <p:cNvSpPr/>
-          <p:nvPr/>
-        </p:nvSpPr>
-        <p:spPr>
-          <a:xfrm>
-            <a:off x="457200" y="6400800"/>
-            <a:ext cx="11247120" cy="635"/>
-          </a:xfrm>
-          <a:custGeom>
-            <a:avLst/>
-            <a:gdLst/>
-            <a:ahLst/>
-            <a:cxnLst/>
-            <a:rect l="l" t="t" r="r" b="b"/>
-            <a:pathLst>
-              <a:path w="11247120" h="635">
-                <a:moveTo>
-                  <a:pt x="0" y="0"/>
-                </a:moveTo>
-                <a:lnTo>
-                  <a:pt x="11247120" y="355"/>
-                </a:lnTo>
-              </a:path>
-            </a:pathLst>
-          </a:custGeom>
-          <a:ln w="6479">
-            <a:solidFill>
-              <a:srgbClr val="C7C7C7"/>
-            </a:solidFill>
-          </a:ln>
-        </p:spPr>
-        <p:txBody>
-          <a:bodyPr wrap="square" lIns="0" tIns="0" rIns="0" bIns="0" rtlCol="0"/>
-          <a:lstStyle/>
-          <a:p>
-            <a:endParaRPr/>
-          </a:p>
-        </p:txBody>
-      </p:sp>
-      <p:sp>
-        <p:nvSpPr>
-          <p:cNvPr id="4" name="object 4"/>
-          <p:cNvSpPr txBox="1"/>
-          <p:nvPr/>
-        </p:nvSpPr>
-        <p:spPr>
-          <a:xfrm>
-            <a:off x="991336" y="1794788"/>
-            <a:ext cx="2747010" cy="299720"/>
-          </a:xfrm>
-          <a:prstGeom prst="rect">
-            <a:avLst/>
-          </a:prstGeom>
-        </p:spPr>
-        <p:txBody>
-          <a:bodyPr vert="horz" wrap="square" lIns="0" tIns="12700" rIns="0" bIns="0" rtlCol="0">
-            <a:spAutoFit/>
-          </a:bodyPr>
-          <a:lstStyle/>
-          <a:p>
-            <a:pPr marL="12700">
-              <a:lnSpc>
-                <a:spcPct val="100000"/>
-              </a:lnSpc>
-              <a:spcBef>
-                <a:spcPts val="100"/>
-              </a:spcBef>
-            </a:pPr>
-            <a:r>
-              <a:rPr sz="1800" b="1" dirty="0">
-                <a:solidFill>
-                  <a:srgbClr val="003366"/>
-                </a:solidFill>
-                <a:latin typeface="Calibri"/>
-                <a:cs typeface="Calibri"/>
-              </a:rPr>
-              <a:t>1.</a:t>
-            </a:r>
-            <a:r>
-              <a:rPr sz="1800" b="1" spc="-20" dirty="0">
-                <a:solidFill>
-                  <a:srgbClr val="003366"/>
-                </a:solidFill>
-                <a:latin typeface="Calibri"/>
-                <a:cs typeface="Calibri"/>
-              </a:rPr>
-              <a:t> </a:t>
-            </a:r>
-            <a:r>
-              <a:rPr sz="1800" b="1" dirty="0">
-                <a:solidFill>
-                  <a:srgbClr val="003366"/>
-                </a:solidFill>
-                <a:latin typeface="Calibri"/>
-                <a:cs typeface="Calibri"/>
-              </a:rPr>
-              <a:t>O</a:t>
-            </a:r>
-            <a:r>
-              <a:rPr sz="1800" b="1" spc="-15" dirty="0">
-                <a:solidFill>
-                  <a:srgbClr val="003366"/>
-                </a:solidFill>
-                <a:latin typeface="Calibri"/>
-                <a:cs typeface="Calibri"/>
-              </a:rPr>
-              <a:t> </a:t>
-            </a:r>
-            <a:r>
-              <a:rPr sz="1800" b="1" dirty="0">
-                <a:solidFill>
-                  <a:srgbClr val="003366"/>
-                </a:solidFill>
-                <a:latin typeface="Calibri"/>
-                <a:cs typeface="Calibri"/>
-              </a:rPr>
-              <a:t>problema</a:t>
-            </a:r>
-            <a:r>
-              <a:rPr sz="1800" b="1" spc="-15" dirty="0">
-                <a:solidFill>
-                  <a:srgbClr val="003366"/>
-                </a:solidFill>
-                <a:latin typeface="Calibri"/>
-                <a:cs typeface="Calibri"/>
-              </a:rPr>
-              <a:t> </a:t>
-            </a:r>
-            <a:r>
-              <a:rPr sz="1800" b="1" dirty="0">
-                <a:solidFill>
-                  <a:srgbClr val="003366"/>
-                </a:solidFill>
-                <a:latin typeface="Calibri"/>
-                <a:cs typeface="Calibri"/>
-              </a:rPr>
-              <a:t>e</a:t>
-            </a:r>
-            <a:r>
-              <a:rPr sz="1800" b="1" spc="-10" dirty="0">
-                <a:solidFill>
-                  <a:srgbClr val="003366"/>
-                </a:solidFill>
-                <a:latin typeface="Calibri"/>
-                <a:cs typeface="Calibri"/>
-              </a:rPr>
-              <a:t> </a:t>
-            </a:r>
-            <a:r>
-              <a:rPr sz="1800" b="1" dirty="0">
-                <a:solidFill>
-                  <a:srgbClr val="003366"/>
-                </a:solidFill>
-                <a:latin typeface="Calibri"/>
-                <a:cs typeface="Calibri"/>
-              </a:rPr>
-              <a:t>a</a:t>
-            </a:r>
-            <a:r>
-              <a:rPr sz="1800" b="1" spc="-20" dirty="0">
-                <a:solidFill>
-                  <a:srgbClr val="003366"/>
-                </a:solidFill>
-                <a:latin typeface="Calibri"/>
-                <a:cs typeface="Calibri"/>
-              </a:rPr>
-              <a:t> </a:t>
-            </a:r>
-            <a:r>
-              <a:rPr sz="1800" b="1" spc="-10" dirty="0">
-                <a:solidFill>
-                  <a:srgbClr val="003366"/>
-                </a:solidFill>
-                <a:latin typeface="Calibri"/>
-                <a:cs typeface="Calibri"/>
-              </a:rPr>
-              <a:t>motivação</a:t>
-            </a:r>
-            <a:endParaRPr sz="1800" dirty="0">
-              <a:latin typeface="Calibri"/>
-              <a:cs typeface="Calibri"/>
-            </a:endParaRPr>
-          </a:p>
-        </p:txBody>
-      </p:sp>
-      <p:sp>
-        <p:nvSpPr>
-          <p:cNvPr id="5" name="object 5"/>
-          <p:cNvSpPr txBox="1"/>
-          <p:nvPr/>
-        </p:nvSpPr>
-        <p:spPr>
-          <a:xfrm>
-            <a:off x="991336" y="2667774"/>
-            <a:ext cx="2121535" cy="299720"/>
-          </a:xfrm>
-          <a:prstGeom prst="rect">
-            <a:avLst/>
-          </a:prstGeom>
-        </p:spPr>
-        <p:txBody>
-          <a:bodyPr vert="horz" wrap="square" lIns="0" tIns="12700" rIns="0" bIns="0" rtlCol="0">
-            <a:spAutoFit/>
-          </a:bodyPr>
-          <a:lstStyle/>
-          <a:p>
-            <a:pPr marL="12700">
-              <a:lnSpc>
-                <a:spcPct val="100000"/>
-              </a:lnSpc>
-              <a:spcBef>
-                <a:spcPts val="100"/>
-              </a:spcBef>
-            </a:pPr>
-            <a:r>
-              <a:rPr sz="1800" b="1" dirty="0">
-                <a:solidFill>
-                  <a:srgbClr val="003366"/>
-                </a:solidFill>
-                <a:latin typeface="Calibri"/>
-                <a:cs typeface="Calibri"/>
-              </a:rPr>
-              <a:t>2.</a:t>
-            </a:r>
-            <a:r>
-              <a:rPr sz="1800" b="1" spc="-35" dirty="0">
-                <a:solidFill>
-                  <a:srgbClr val="003366"/>
-                </a:solidFill>
-                <a:latin typeface="Calibri"/>
-                <a:cs typeface="Calibri"/>
-              </a:rPr>
-              <a:t> </a:t>
-            </a:r>
-            <a:r>
-              <a:rPr sz="1800" b="1" dirty="0">
-                <a:solidFill>
-                  <a:srgbClr val="003366"/>
-                </a:solidFill>
-                <a:latin typeface="Calibri"/>
-                <a:cs typeface="Calibri"/>
-              </a:rPr>
-              <a:t>O</a:t>
-            </a:r>
-            <a:r>
-              <a:rPr sz="1800" b="1" spc="-30" dirty="0">
-                <a:solidFill>
-                  <a:srgbClr val="003366"/>
-                </a:solidFill>
-                <a:latin typeface="Calibri"/>
-                <a:cs typeface="Calibri"/>
-              </a:rPr>
-              <a:t> </a:t>
-            </a:r>
-            <a:r>
-              <a:rPr sz="1800" b="1" dirty="0">
-                <a:solidFill>
-                  <a:srgbClr val="003366"/>
-                </a:solidFill>
-                <a:latin typeface="Calibri"/>
-                <a:cs typeface="Calibri"/>
-              </a:rPr>
-              <a:t>dataset</a:t>
-            </a:r>
-            <a:r>
-              <a:rPr sz="1800" b="1" spc="-30" dirty="0">
-                <a:solidFill>
-                  <a:srgbClr val="003366"/>
-                </a:solidFill>
-                <a:latin typeface="Calibri"/>
-                <a:cs typeface="Calibri"/>
-              </a:rPr>
-              <a:t> </a:t>
-            </a:r>
-            <a:r>
-              <a:rPr sz="1800" b="1" spc="-10" dirty="0">
-                <a:solidFill>
-                  <a:srgbClr val="003366"/>
-                </a:solidFill>
-                <a:latin typeface="Calibri"/>
-                <a:cs typeface="Calibri"/>
-              </a:rPr>
-              <a:t>escolhido</a:t>
-            </a:r>
-            <a:endParaRPr sz="1800" dirty="0">
-              <a:latin typeface="Calibri"/>
-              <a:cs typeface="Calibri"/>
-            </a:endParaRPr>
-          </a:p>
-        </p:txBody>
-      </p:sp>
-      <p:sp>
-        <p:nvSpPr>
-          <p:cNvPr id="6" name="object 6"/>
-          <p:cNvSpPr txBox="1"/>
-          <p:nvPr/>
-        </p:nvSpPr>
-        <p:spPr>
-          <a:xfrm>
-            <a:off x="994612" y="3540760"/>
-            <a:ext cx="2345690" cy="299720"/>
-          </a:xfrm>
-          <a:prstGeom prst="rect">
-            <a:avLst/>
-          </a:prstGeom>
-        </p:spPr>
-        <p:txBody>
-          <a:bodyPr vert="horz" wrap="square" lIns="0" tIns="12700" rIns="0" bIns="0" rtlCol="0">
-            <a:spAutoFit/>
-          </a:bodyPr>
-          <a:lstStyle/>
-          <a:p>
-            <a:pPr marL="12700">
-              <a:lnSpc>
-                <a:spcPct val="100000"/>
-              </a:lnSpc>
-              <a:spcBef>
-                <a:spcPts val="100"/>
-              </a:spcBef>
-            </a:pPr>
-            <a:r>
-              <a:rPr sz="1800" b="1" dirty="0">
-                <a:solidFill>
-                  <a:srgbClr val="003366"/>
-                </a:solidFill>
-                <a:latin typeface="Calibri"/>
-                <a:cs typeface="Calibri"/>
-              </a:rPr>
-              <a:t>3.</a:t>
-            </a:r>
-            <a:r>
-              <a:rPr sz="1800" b="1" spc="-20" dirty="0">
-                <a:solidFill>
-                  <a:srgbClr val="003366"/>
-                </a:solidFill>
-                <a:latin typeface="Calibri"/>
-                <a:cs typeface="Calibri"/>
-              </a:rPr>
-              <a:t> </a:t>
-            </a:r>
-            <a:r>
-              <a:rPr sz="1800" b="1" spc="-10" dirty="0">
-                <a:solidFill>
-                  <a:srgbClr val="003366"/>
-                </a:solidFill>
-                <a:latin typeface="Calibri"/>
-                <a:cs typeface="Calibri"/>
-              </a:rPr>
-              <a:t>Arquitetura</a:t>
-            </a:r>
-            <a:r>
-              <a:rPr sz="1800" b="1" spc="-15" dirty="0">
-                <a:solidFill>
-                  <a:srgbClr val="003366"/>
-                </a:solidFill>
-                <a:latin typeface="Calibri"/>
-                <a:cs typeface="Calibri"/>
-              </a:rPr>
-              <a:t> </a:t>
-            </a:r>
-            <a:r>
-              <a:rPr sz="1800" b="1" dirty="0">
-                <a:solidFill>
-                  <a:srgbClr val="003366"/>
-                </a:solidFill>
-                <a:latin typeface="Calibri"/>
-                <a:cs typeface="Calibri"/>
-              </a:rPr>
-              <a:t>do</a:t>
-            </a:r>
-            <a:r>
-              <a:rPr sz="1800" b="1" spc="-10" dirty="0">
-                <a:solidFill>
-                  <a:srgbClr val="003366"/>
-                </a:solidFill>
-                <a:latin typeface="Calibri"/>
-                <a:cs typeface="Calibri"/>
-              </a:rPr>
-              <a:t> agente</a:t>
-            </a:r>
-            <a:endParaRPr sz="1800" dirty="0">
-              <a:latin typeface="Calibri"/>
-              <a:cs typeface="Calibri"/>
-            </a:endParaRPr>
-          </a:p>
-        </p:txBody>
-      </p:sp>
-      <p:sp>
-        <p:nvSpPr>
-          <p:cNvPr id="7" name="object 7"/>
-          <p:cNvSpPr txBox="1"/>
-          <p:nvPr/>
-        </p:nvSpPr>
-        <p:spPr>
-          <a:xfrm>
-            <a:off x="991336" y="4415612"/>
-            <a:ext cx="2964815" cy="299720"/>
-          </a:xfrm>
-          <a:prstGeom prst="rect">
-            <a:avLst/>
-          </a:prstGeom>
-        </p:spPr>
-        <p:txBody>
-          <a:bodyPr vert="horz" wrap="square" lIns="0" tIns="12700" rIns="0" bIns="0" rtlCol="0">
-            <a:spAutoFit/>
-          </a:bodyPr>
-          <a:lstStyle/>
-          <a:p>
-            <a:pPr marL="12700">
-              <a:lnSpc>
-                <a:spcPct val="100000"/>
-              </a:lnSpc>
-              <a:spcBef>
-                <a:spcPts val="100"/>
-              </a:spcBef>
-            </a:pPr>
-            <a:r>
-              <a:rPr sz="1800" b="1" dirty="0">
-                <a:solidFill>
-                  <a:srgbClr val="003366"/>
-                </a:solidFill>
-                <a:latin typeface="Calibri"/>
-                <a:cs typeface="Calibri"/>
-              </a:rPr>
-              <a:t>4.</a:t>
-            </a:r>
-            <a:r>
-              <a:rPr sz="1800" b="1" spc="-35" dirty="0">
-                <a:solidFill>
-                  <a:srgbClr val="003366"/>
-                </a:solidFill>
-                <a:latin typeface="Calibri"/>
-                <a:cs typeface="Calibri"/>
-              </a:rPr>
-              <a:t> </a:t>
-            </a:r>
-            <a:r>
-              <a:rPr sz="1800" b="1" spc="-10" dirty="0">
-                <a:solidFill>
-                  <a:srgbClr val="003366"/>
-                </a:solidFill>
-                <a:latin typeface="Calibri"/>
-                <a:cs typeface="Calibri"/>
-              </a:rPr>
-              <a:t>Ferramentas</a:t>
-            </a:r>
-            <a:r>
-              <a:rPr sz="1800" b="1" spc="-25" dirty="0">
-                <a:solidFill>
-                  <a:srgbClr val="003366"/>
-                </a:solidFill>
-                <a:latin typeface="Calibri"/>
-                <a:cs typeface="Calibri"/>
-              </a:rPr>
-              <a:t> </a:t>
-            </a:r>
-            <a:r>
-              <a:rPr sz="1800" b="1" spc="-10" dirty="0">
-                <a:solidFill>
-                  <a:srgbClr val="003366"/>
-                </a:solidFill>
-                <a:latin typeface="Calibri"/>
-                <a:cs typeface="Calibri"/>
-              </a:rPr>
-              <a:t>implementadas</a:t>
-            </a:r>
-            <a:endParaRPr sz="1800" dirty="0">
-              <a:latin typeface="Calibri"/>
-              <a:cs typeface="Calibri"/>
-            </a:endParaRPr>
-          </a:p>
-        </p:txBody>
-      </p:sp>
-      <p:sp>
-        <p:nvSpPr>
-          <p:cNvPr id="8" name="object 8"/>
-          <p:cNvSpPr txBox="1"/>
-          <p:nvPr/>
-        </p:nvSpPr>
-        <p:spPr>
-          <a:xfrm>
-            <a:off x="1018768" y="5288598"/>
-            <a:ext cx="2361565" cy="299720"/>
-          </a:xfrm>
-          <a:prstGeom prst="rect">
-            <a:avLst/>
-          </a:prstGeom>
-        </p:spPr>
-        <p:txBody>
-          <a:bodyPr vert="horz" wrap="square" lIns="0" tIns="12700" rIns="0" bIns="0" rtlCol="0">
-            <a:spAutoFit/>
-          </a:bodyPr>
-          <a:lstStyle/>
-          <a:p>
-            <a:pPr marL="12700">
-              <a:lnSpc>
-                <a:spcPct val="100000"/>
-              </a:lnSpc>
-              <a:spcBef>
-                <a:spcPts val="100"/>
-              </a:spcBef>
-            </a:pPr>
-            <a:r>
-              <a:rPr sz="1800" b="1" dirty="0">
-                <a:solidFill>
-                  <a:srgbClr val="003366"/>
-                </a:solidFill>
-                <a:latin typeface="Calibri"/>
-                <a:cs typeface="Calibri"/>
-              </a:rPr>
-              <a:t>5.</a:t>
-            </a:r>
-            <a:r>
-              <a:rPr sz="1800" b="1" spc="-15" dirty="0">
-                <a:solidFill>
-                  <a:srgbClr val="003366"/>
-                </a:solidFill>
-                <a:latin typeface="Calibri"/>
-                <a:cs typeface="Calibri"/>
-              </a:rPr>
-              <a:t> </a:t>
-            </a:r>
-            <a:r>
-              <a:rPr sz="1800" b="1" spc="-10" dirty="0">
-                <a:solidFill>
-                  <a:srgbClr val="003366"/>
-                </a:solidFill>
-                <a:latin typeface="Calibri"/>
-                <a:cs typeface="Calibri"/>
-              </a:rPr>
-              <a:t>Demonstração</a:t>
-            </a:r>
-            <a:r>
-              <a:rPr sz="1800" b="1" spc="-15" dirty="0">
-                <a:solidFill>
-                  <a:srgbClr val="003366"/>
-                </a:solidFill>
-                <a:latin typeface="Calibri"/>
-                <a:cs typeface="Calibri"/>
-              </a:rPr>
-              <a:t> </a:t>
-            </a:r>
-            <a:r>
-              <a:rPr sz="1800" b="1" dirty="0">
-                <a:solidFill>
-                  <a:srgbClr val="003366"/>
-                </a:solidFill>
-                <a:latin typeface="Calibri"/>
-                <a:cs typeface="Calibri"/>
-              </a:rPr>
-              <a:t>ao</a:t>
-            </a:r>
-            <a:r>
-              <a:rPr sz="1800" b="1" spc="-5" dirty="0">
-                <a:solidFill>
-                  <a:srgbClr val="003366"/>
-                </a:solidFill>
-                <a:latin typeface="Calibri"/>
-                <a:cs typeface="Calibri"/>
-              </a:rPr>
-              <a:t> </a:t>
-            </a:r>
-            <a:r>
-              <a:rPr sz="1800" b="1" spc="-20" dirty="0">
-                <a:solidFill>
-                  <a:srgbClr val="003366"/>
-                </a:solidFill>
-                <a:latin typeface="Calibri"/>
-                <a:cs typeface="Calibri"/>
-              </a:rPr>
-              <a:t>vivo</a:t>
-            </a:r>
-            <a:endParaRPr sz="1800" dirty="0">
-              <a:latin typeface="Calibri"/>
-              <a:cs typeface="Calibri"/>
-            </a:endParaRPr>
-          </a:p>
-        </p:txBody>
-      </p:sp>
-      <p:sp>
-        <p:nvSpPr>
-          <p:cNvPr id="9" name="object 9"/>
-          <p:cNvSpPr txBox="1"/>
-          <p:nvPr/>
-        </p:nvSpPr>
-        <p:spPr>
-          <a:xfrm>
-            <a:off x="6404330" y="1794788"/>
-            <a:ext cx="3604260" cy="299720"/>
-          </a:xfrm>
-          <a:prstGeom prst="rect">
-            <a:avLst/>
-          </a:prstGeom>
-        </p:spPr>
-        <p:txBody>
-          <a:bodyPr vert="horz" wrap="square" lIns="0" tIns="12700" rIns="0" bIns="0" rtlCol="0">
-            <a:spAutoFit/>
-          </a:bodyPr>
-          <a:lstStyle/>
-          <a:p>
-            <a:pPr marL="12700">
-              <a:lnSpc>
-                <a:spcPct val="100000"/>
-              </a:lnSpc>
-              <a:spcBef>
-                <a:spcPts val="100"/>
-              </a:spcBef>
-            </a:pPr>
-            <a:r>
-              <a:rPr sz="1800" b="1" dirty="0">
-                <a:solidFill>
-                  <a:srgbClr val="003366"/>
-                </a:solidFill>
-                <a:latin typeface="Calibri"/>
-                <a:cs typeface="Calibri"/>
-              </a:rPr>
-              <a:t>6.</a:t>
-            </a:r>
-            <a:r>
-              <a:rPr sz="1800" b="1" spc="-50" dirty="0">
-                <a:solidFill>
-                  <a:srgbClr val="003366"/>
-                </a:solidFill>
-                <a:latin typeface="Calibri"/>
-                <a:cs typeface="Calibri"/>
-              </a:rPr>
-              <a:t> </a:t>
-            </a:r>
-            <a:r>
-              <a:rPr sz="1800" b="1" dirty="0">
-                <a:solidFill>
-                  <a:srgbClr val="003366"/>
-                </a:solidFill>
-                <a:latin typeface="Calibri"/>
-                <a:cs typeface="Calibri"/>
-              </a:rPr>
-              <a:t>Conjunto</a:t>
-            </a:r>
-            <a:r>
-              <a:rPr sz="1800" b="1" spc="-40" dirty="0">
-                <a:solidFill>
-                  <a:srgbClr val="003366"/>
-                </a:solidFill>
-                <a:latin typeface="Calibri"/>
-                <a:cs typeface="Calibri"/>
-              </a:rPr>
-              <a:t> </a:t>
-            </a:r>
-            <a:r>
-              <a:rPr sz="1800" b="1" dirty="0">
-                <a:solidFill>
-                  <a:srgbClr val="003366"/>
-                </a:solidFill>
-                <a:latin typeface="Calibri"/>
-                <a:cs typeface="Calibri"/>
-              </a:rPr>
-              <a:t>de</a:t>
-            </a:r>
-            <a:r>
-              <a:rPr sz="1800" b="1" spc="-50" dirty="0">
-                <a:solidFill>
-                  <a:srgbClr val="003366"/>
-                </a:solidFill>
-                <a:latin typeface="Calibri"/>
-                <a:cs typeface="Calibri"/>
-              </a:rPr>
-              <a:t> </a:t>
-            </a:r>
-            <a:r>
-              <a:rPr sz="1800" b="1" dirty="0">
-                <a:solidFill>
-                  <a:srgbClr val="003366"/>
-                </a:solidFill>
-                <a:latin typeface="Calibri"/>
-                <a:cs typeface="Calibri"/>
-              </a:rPr>
-              <a:t>avaliação</a:t>
-            </a:r>
-            <a:r>
-              <a:rPr sz="1800" b="1" spc="-45" dirty="0">
-                <a:solidFill>
-                  <a:srgbClr val="003366"/>
-                </a:solidFill>
-                <a:latin typeface="Calibri"/>
-                <a:cs typeface="Calibri"/>
-              </a:rPr>
-              <a:t> </a:t>
-            </a:r>
-            <a:r>
-              <a:rPr sz="1800" b="1" spc="-10" dirty="0">
-                <a:solidFill>
-                  <a:srgbClr val="003366"/>
-                </a:solidFill>
-                <a:latin typeface="Calibri"/>
-                <a:cs typeface="Calibri"/>
-              </a:rPr>
-              <a:t>(benchmark)</a:t>
-            </a:r>
-            <a:endParaRPr sz="1800" dirty="0">
-              <a:latin typeface="Calibri"/>
-              <a:cs typeface="Calibri"/>
-            </a:endParaRPr>
-          </a:p>
-        </p:txBody>
-      </p:sp>
-      <p:sp>
-        <p:nvSpPr>
-          <p:cNvPr id="10" name="object 10"/>
-          <p:cNvSpPr txBox="1"/>
-          <p:nvPr/>
-        </p:nvSpPr>
-        <p:spPr>
-          <a:xfrm>
-            <a:off x="6401155" y="2665908"/>
-            <a:ext cx="2593975" cy="299720"/>
-          </a:xfrm>
-          <a:prstGeom prst="rect">
-            <a:avLst/>
-          </a:prstGeom>
-        </p:spPr>
-        <p:txBody>
-          <a:bodyPr vert="horz" wrap="square" lIns="0" tIns="12700" rIns="0" bIns="0" rtlCol="0">
-            <a:spAutoFit/>
-          </a:bodyPr>
-          <a:lstStyle/>
-          <a:p>
-            <a:pPr marL="12700">
-              <a:lnSpc>
-                <a:spcPct val="100000"/>
-              </a:lnSpc>
-              <a:spcBef>
-                <a:spcPts val="100"/>
-              </a:spcBef>
-            </a:pPr>
-            <a:r>
-              <a:rPr sz="1800" b="1" dirty="0">
-                <a:solidFill>
-                  <a:srgbClr val="003366"/>
-                </a:solidFill>
-                <a:latin typeface="Calibri"/>
-                <a:cs typeface="Calibri"/>
-              </a:rPr>
-              <a:t>7.</a:t>
-            </a:r>
-            <a:r>
-              <a:rPr sz="1800" b="1" spc="-55" dirty="0">
-                <a:solidFill>
-                  <a:srgbClr val="003366"/>
-                </a:solidFill>
-                <a:latin typeface="Calibri"/>
-                <a:cs typeface="Calibri"/>
-              </a:rPr>
-              <a:t> </a:t>
-            </a:r>
-            <a:r>
-              <a:rPr sz="1800" b="1" dirty="0">
-                <a:solidFill>
-                  <a:srgbClr val="003366"/>
-                </a:solidFill>
-                <a:latin typeface="Calibri"/>
-                <a:cs typeface="Calibri"/>
-              </a:rPr>
-              <a:t>Resultados</a:t>
-            </a:r>
-            <a:r>
-              <a:rPr sz="1800" b="1" spc="-45" dirty="0">
-                <a:solidFill>
-                  <a:srgbClr val="003366"/>
-                </a:solidFill>
-                <a:latin typeface="Calibri"/>
-                <a:cs typeface="Calibri"/>
-              </a:rPr>
-              <a:t> </a:t>
-            </a:r>
-            <a:r>
-              <a:rPr sz="1800" b="1" spc="-10" dirty="0">
-                <a:solidFill>
-                  <a:srgbClr val="003366"/>
-                </a:solidFill>
-                <a:latin typeface="Calibri"/>
-                <a:cs typeface="Calibri"/>
-              </a:rPr>
-              <a:t>quantitativos</a:t>
-            </a:r>
-            <a:endParaRPr sz="1800" dirty="0">
-              <a:latin typeface="Calibri"/>
-              <a:cs typeface="Calibri"/>
-            </a:endParaRPr>
-          </a:p>
-        </p:txBody>
-      </p:sp>
-      <p:sp>
-        <p:nvSpPr>
-          <p:cNvPr id="11" name="object 11"/>
-          <p:cNvSpPr txBox="1"/>
-          <p:nvPr/>
-        </p:nvSpPr>
-        <p:spPr>
-          <a:xfrm>
-            <a:off x="6401155" y="3540760"/>
-            <a:ext cx="2973070" cy="299720"/>
-          </a:xfrm>
-          <a:prstGeom prst="rect">
-            <a:avLst/>
-          </a:prstGeom>
-        </p:spPr>
-        <p:txBody>
-          <a:bodyPr vert="horz" wrap="square" lIns="0" tIns="12700" rIns="0" bIns="0" rtlCol="0">
-            <a:spAutoFit/>
-          </a:bodyPr>
-          <a:lstStyle/>
-          <a:p>
-            <a:pPr marL="12700">
-              <a:lnSpc>
-                <a:spcPct val="100000"/>
-              </a:lnSpc>
-              <a:spcBef>
-                <a:spcPts val="100"/>
-              </a:spcBef>
-            </a:pPr>
-            <a:r>
-              <a:rPr sz="1800" b="1" dirty="0">
-                <a:solidFill>
-                  <a:srgbClr val="003366"/>
-                </a:solidFill>
-                <a:latin typeface="Calibri"/>
-                <a:cs typeface="Calibri"/>
-              </a:rPr>
-              <a:t>8.</a:t>
-            </a:r>
-            <a:r>
-              <a:rPr sz="1800" b="1" spc="-20" dirty="0">
-                <a:solidFill>
-                  <a:srgbClr val="003366"/>
-                </a:solidFill>
-                <a:latin typeface="Calibri"/>
-                <a:cs typeface="Calibri"/>
-              </a:rPr>
-              <a:t> </a:t>
-            </a:r>
-            <a:r>
-              <a:rPr sz="1800" b="1" dirty="0">
-                <a:solidFill>
-                  <a:srgbClr val="003366"/>
-                </a:solidFill>
-                <a:latin typeface="Calibri"/>
-                <a:cs typeface="Calibri"/>
-              </a:rPr>
-              <a:t>Análise</a:t>
-            </a:r>
-            <a:r>
-              <a:rPr sz="1800" b="1" spc="-10" dirty="0">
-                <a:solidFill>
-                  <a:srgbClr val="003366"/>
-                </a:solidFill>
-                <a:latin typeface="Calibri"/>
-                <a:cs typeface="Calibri"/>
-              </a:rPr>
-              <a:t> </a:t>
-            </a:r>
-            <a:r>
-              <a:rPr sz="1800" b="1" dirty="0">
-                <a:solidFill>
-                  <a:srgbClr val="003366"/>
-                </a:solidFill>
-                <a:latin typeface="Calibri"/>
-                <a:cs typeface="Calibri"/>
-              </a:rPr>
-              <a:t>de</a:t>
-            </a:r>
-            <a:r>
-              <a:rPr sz="1800" b="1" spc="-15" dirty="0">
-                <a:solidFill>
-                  <a:srgbClr val="003366"/>
-                </a:solidFill>
-                <a:latin typeface="Calibri"/>
-                <a:cs typeface="Calibri"/>
-              </a:rPr>
-              <a:t> </a:t>
-            </a:r>
-            <a:r>
-              <a:rPr sz="1800" b="1" spc="-10" dirty="0">
-                <a:solidFill>
-                  <a:srgbClr val="003366"/>
-                </a:solidFill>
-                <a:latin typeface="Calibri"/>
-                <a:cs typeface="Calibri"/>
-              </a:rPr>
-              <a:t>trajetórias </a:t>
-            </a:r>
-            <a:r>
-              <a:rPr sz="1800" b="1" dirty="0">
-                <a:solidFill>
-                  <a:srgbClr val="003366"/>
-                </a:solidFill>
-                <a:latin typeface="Calibri"/>
-                <a:cs typeface="Calibri"/>
-              </a:rPr>
-              <a:t>e</a:t>
-            </a:r>
-            <a:r>
-              <a:rPr sz="1800" b="1" spc="-15" dirty="0">
-                <a:solidFill>
-                  <a:srgbClr val="003366"/>
-                </a:solidFill>
-                <a:latin typeface="Calibri"/>
-                <a:cs typeface="Calibri"/>
-              </a:rPr>
-              <a:t> </a:t>
-            </a:r>
-            <a:r>
-              <a:rPr sz="1800" b="1" spc="-20" dirty="0">
-                <a:solidFill>
-                  <a:srgbClr val="003366"/>
-                </a:solidFill>
-                <a:latin typeface="Calibri"/>
-                <a:cs typeface="Calibri"/>
-              </a:rPr>
-              <a:t>erros</a:t>
-            </a:r>
-            <a:endParaRPr sz="1800" dirty="0">
-              <a:latin typeface="Calibri"/>
-              <a:cs typeface="Calibri"/>
-            </a:endParaRPr>
-          </a:p>
-        </p:txBody>
-      </p:sp>
-      <p:sp>
-        <p:nvSpPr>
-          <p:cNvPr id="12" name="object 12"/>
-          <p:cNvSpPr txBox="1"/>
-          <p:nvPr/>
-        </p:nvSpPr>
-        <p:spPr>
-          <a:xfrm>
-            <a:off x="6401155" y="4415612"/>
-            <a:ext cx="1805305" cy="299720"/>
-          </a:xfrm>
-          <a:prstGeom prst="rect">
-            <a:avLst/>
-          </a:prstGeom>
-        </p:spPr>
-        <p:txBody>
-          <a:bodyPr vert="horz" wrap="square" lIns="0" tIns="12700" rIns="0" bIns="0" rtlCol="0">
-            <a:spAutoFit/>
-          </a:bodyPr>
-          <a:lstStyle/>
-          <a:p>
-            <a:pPr marL="12700">
-              <a:lnSpc>
-                <a:spcPct val="100000"/>
-              </a:lnSpc>
-              <a:spcBef>
-                <a:spcPts val="100"/>
-              </a:spcBef>
-            </a:pPr>
-            <a:r>
-              <a:rPr sz="1800" b="1" dirty="0">
-                <a:solidFill>
-                  <a:srgbClr val="003366"/>
-                </a:solidFill>
-                <a:latin typeface="Calibri"/>
-                <a:cs typeface="Calibri"/>
-              </a:rPr>
-              <a:t>9.</a:t>
-            </a:r>
-            <a:r>
-              <a:rPr sz="1800" b="1" spc="-25" dirty="0">
-                <a:solidFill>
-                  <a:srgbClr val="003366"/>
-                </a:solidFill>
-                <a:latin typeface="Calibri"/>
-                <a:cs typeface="Calibri"/>
-              </a:rPr>
-              <a:t> </a:t>
-            </a:r>
-            <a:r>
-              <a:rPr sz="1800" b="1" dirty="0">
-                <a:solidFill>
-                  <a:srgbClr val="003366"/>
-                </a:solidFill>
-                <a:latin typeface="Calibri"/>
-                <a:cs typeface="Calibri"/>
-              </a:rPr>
-              <a:t>Discussão</a:t>
-            </a:r>
-            <a:r>
-              <a:rPr sz="1800" b="1" spc="-30" dirty="0">
-                <a:solidFill>
-                  <a:srgbClr val="003366"/>
-                </a:solidFill>
-                <a:latin typeface="Calibri"/>
-                <a:cs typeface="Calibri"/>
-              </a:rPr>
-              <a:t> </a:t>
-            </a:r>
-            <a:r>
-              <a:rPr sz="1800" b="1" spc="-10" dirty="0">
-                <a:solidFill>
-                  <a:srgbClr val="003366"/>
-                </a:solidFill>
-                <a:latin typeface="Calibri"/>
-                <a:cs typeface="Calibri"/>
-              </a:rPr>
-              <a:t>crítica</a:t>
-            </a:r>
-            <a:endParaRPr sz="1800" dirty="0">
-              <a:latin typeface="Calibri"/>
-              <a:cs typeface="Calibri"/>
-            </a:endParaRPr>
-          </a:p>
-        </p:txBody>
-      </p:sp>
-      <p:sp>
-        <p:nvSpPr>
-          <p:cNvPr id="13" name="object 13"/>
-          <p:cNvSpPr txBox="1"/>
-          <p:nvPr/>
-        </p:nvSpPr>
-        <p:spPr>
-          <a:xfrm>
-            <a:off x="6401155" y="5288598"/>
-            <a:ext cx="3282315" cy="299720"/>
-          </a:xfrm>
-          <a:prstGeom prst="rect">
-            <a:avLst/>
-          </a:prstGeom>
-        </p:spPr>
-        <p:txBody>
-          <a:bodyPr vert="horz" wrap="square" lIns="0" tIns="12700" rIns="0" bIns="0" rtlCol="0">
-            <a:spAutoFit/>
-          </a:bodyPr>
-          <a:lstStyle/>
-          <a:p>
-            <a:pPr marL="12700">
-              <a:lnSpc>
-                <a:spcPct val="100000"/>
-              </a:lnSpc>
-              <a:spcBef>
-                <a:spcPts val="100"/>
-              </a:spcBef>
-            </a:pPr>
-            <a:r>
-              <a:rPr sz="1800" b="1" dirty="0">
-                <a:solidFill>
-                  <a:srgbClr val="003366"/>
-                </a:solidFill>
-                <a:latin typeface="Calibri"/>
-                <a:cs typeface="Calibri"/>
-              </a:rPr>
-              <a:t>10.</a:t>
-            </a:r>
-            <a:r>
-              <a:rPr sz="1800" b="1" spc="-35" dirty="0">
-                <a:solidFill>
-                  <a:srgbClr val="003366"/>
-                </a:solidFill>
-                <a:latin typeface="Calibri"/>
-                <a:cs typeface="Calibri"/>
-              </a:rPr>
-              <a:t> </a:t>
-            </a:r>
-            <a:r>
-              <a:rPr sz="1800" b="1" dirty="0">
-                <a:solidFill>
-                  <a:srgbClr val="003366"/>
-                </a:solidFill>
-                <a:latin typeface="Calibri"/>
-                <a:cs typeface="Calibri"/>
-              </a:rPr>
-              <a:t>Conclusões</a:t>
-            </a:r>
-            <a:r>
-              <a:rPr sz="1800" b="1" spc="-30" dirty="0">
-                <a:solidFill>
-                  <a:srgbClr val="003366"/>
-                </a:solidFill>
-                <a:latin typeface="Calibri"/>
-                <a:cs typeface="Calibri"/>
-              </a:rPr>
-              <a:t> </a:t>
-            </a:r>
-            <a:r>
-              <a:rPr sz="1800" b="1" dirty="0">
-                <a:solidFill>
-                  <a:srgbClr val="003366"/>
-                </a:solidFill>
-                <a:latin typeface="Calibri"/>
-                <a:cs typeface="Calibri"/>
-              </a:rPr>
-              <a:t>e</a:t>
-            </a:r>
-            <a:r>
-              <a:rPr sz="1800" b="1" spc="-35" dirty="0">
-                <a:solidFill>
-                  <a:srgbClr val="003366"/>
-                </a:solidFill>
-                <a:latin typeface="Calibri"/>
-                <a:cs typeface="Calibri"/>
-              </a:rPr>
-              <a:t> </a:t>
-            </a:r>
-            <a:r>
-              <a:rPr sz="1800" b="1" dirty="0">
-                <a:solidFill>
-                  <a:srgbClr val="003366"/>
-                </a:solidFill>
-                <a:latin typeface="Calibri"/>
-                <a:cs typeface="Calibri"/>
-              </a:rPr>
-              <a:t>trabalhos</a:t>
-            </a:r>
-            <a:r>
-              <a:rPr sz="1800" b="1" spc="-25" dirty="0">
-                <a:solidFill>
-                  <a:srgbClr val="003366"/>
-                </a:solidFill>
-                <a:latin typeface="Calibri"/>
-                <a:cs typeface="Calibri"/>
-              </a:rPr>
-              <a:t> </a:t>
-            </a:r>
-            <a:r>
-              <a:rPr sz="1800" b="1" spc="-10" dirty="0">
-                <a:solidFill>
-                  <a:srgbClr val="003366"/>
-                </a:solidFill>
-                <a:latin typeface="Calibri"/>
-                <a:cs typeface="Calibri"/>
-              </a:rPr>
-              <a:t>futuros</a:t>
-            </a:r>
-            <a:endParaRPr sz="1800" dirty="0">
-              <a:latin typeface="Calibri"/>
-              <a:cs typeface="Calibri"/>
-            </a:endParaRPr>
-          </a:p>
-        </p:txBody>
-      </p:sp>
-      <p:sp>
-        <p:nvSpPr>
-          <p:cNvPr id="18" name="object 18"/>
-          <p:cNvSpPr txBox="1">
-            <a:spLocks noGrp="1"/>
-          </p:cNvSpPr>
-          <p:nvPr>
-            <p:ph type="ftr" sz="quarter" idx="5"/>
-          </p:nvPr>
-        </p:nvSpPr>
-        <p:spPr>
-          <a:prstGeom prst="rect">
-            <a:avLst/>
-          </a:prstGeom>
-        </p:spPr>
-        <p:txBody>
-          <a:bodyPr vert="horz" wrap="square" lIns="0" tIns="6985" rIns="0" bIns="0" rtlCol="0">
-            <a:spAutoFit/>
-          </a:bodyPr>
-          <a:lstStyle/>
-          <a:p>
-            <a:pPr marL="12700">
-              <a:lnSpc>
-                <a:spcPct val="100000"/>
-              </a:lnSpc>
-              <a:spcBef>
-                <a:spcPts val="55"/>
-              </a:spcBef>
-            </a:pPr>
-            <a:r>
-              <a:rPr spc="-10" dirty="0"/>
-              <a:t>Fatec</a:t>
-            </a:r>
-            <a:r>
-              <a:rPr spc="-30" dirty="0"/>
-              <a:t> </a:t>
-            </a:r>
-            <a:r>
-              <a:rPr dirty="0"/>
-              <a:t>Ourinhos</a:t>
-            </a:r>
-            <a:r>
-              <a:rPr spc="-10" dirty="0"/>
-              <a:t> </a:t>
-            </a:r>
-            <a:r>
-              <a:rPr dirty="0"/>
-              <a:t>|</a:t>
-            </a:r>
-            <a:r>
-              <a:rPr spc="-30" dirty="0"/>
-              <a:t> </a:t>
-            </a:r>
-            <a:r>
-              <a:rPr dirty="0"/>
-              <a:t>Ciência</a:t>
-            </a:r>
-            <a:r>
-              <a:rPr spc="-15" dirty="0"/>
-              <a:t> </a:t>
-            </a:r>
-            <a:r>
-              <a:rPr dirty="0"/>
-              <a:t>de</a:t>
-            </a:r>
-            <a:r>
-              <a:rPr spc="-25" dirty="0"/>
-              <a:t> </a:t>
-            </a:r>
-            <a:r>
-              <a:rPr spc="-20" dirty="0"/>
-              <a:t>Dados</a:t>
-            </a:r>
-          </a:p>
-        </p:txBody>
-      </p:sp>
-      <p:sp>
-        <p:nvSpPr>
-          <p:cNvPr id="19" name="object 19"/>
-          <p:cNvSpPr txBox="1">
-            <a:spLocks noGrp="1"/>
-          </p:cNvSpPr>
-          <p:nvPr>
-            <p:ph type="dt" sz="half" idx="6"/>
-          </p:nvPr>
-        </p:nvSpPr>
-        <p:spPr>
-          <a:prstGeom prst="rect">
-            <a:avLst/>
-          </a:prstGeom>
-        </p:spPr>
-        <p:txBody>
-          <a:bodyPr vert="horz" wrap="square" lIns="0" tIns="6985" rIns="0" bIns="0" rtlCol="0">
-            <a:spAutoFit/>
-          </a:bodyPr>
-          <a:lstStyle/>
-          <a:p>
-            <a:pPr marL="12700">
-              <a:lnSpc>
-                <a:spcPct val="100000"/>
-              </a:lnSpc>
-              <a:spcBef>
-                <a:spcPts val="55"/>
-              </a:spcBef>
-            </a:pPr>
-            <a:r>
-              <a:rPr spc="-10" dirty="0"/>
-              <a:t>Trabalho</a:t>
-            </a:r>
-            <a:r>
-              <a:rPr spc="-25" dirty="0"/>
-              <a:t> </a:t>
-            </a:r>
-            <a:r>
-              <a:rPr dirty="0"/>
-              <a:t>Final</a:t>
-            </a:r>
-            <a:r>
-              <a:rPr spc="-5" dirty="0"/>
-              <a:t> </a:t>
-            </a:r>
-            <a:r>
-              <a:rPr dirty="0"/>
-              <a:t>-</a:t>
-            </a:r>
-            <a:r>
-              <a:rPr spc="-25" dirty="0"/>
-              <a:t> </a:t>
-            </a:r>
-            <a:r>
-              <a:rPr dirty="0"/>
-              <a:t>5º</a:t>
-            </a:r>
-            <a:r>
-              <a:rPr spc="-10" dirty="0"/>
-              <a:t> Semestre</a:t>
-            </a:r>
-          </a:p>
-        </p:txBody>
-      </p:sp>
-      <p:sp>
-        <p:nvSpPr>
-          <p:cNvPr id="20" name="object 20"/>
-          <p:cNvSpPr txBox="1">
-            <a:spLocks noGrp="1"/>
-          </p:cNvSpPr>
-          <p:nvPr>
-            <p:ph type="sldNum" sz="quarter" idx="7"/>
-          </p:nvPr>
-        </p:nvSpPr>
-        <p:spPr>
-          <a:prstGeom prst="rect">
-            <a:avLst/>
-          </a:prstGeom>
-        </p:spPr>
-        <p:txBody>
-          <a:bodyPr vert="horz" wrap="square" lIns="0" tIns="6985" rIns="0" bIns="0" rtlCol="0">
-            <a:spAutoFit/>
-          </a:bodyPr>
-          <a:lstStyle/>
-          <a:p>
-            <a:pPr marL="12700">
-              <a:lnSpc>
-                <a:spcPct val="100000"/>
-              </a:lnSpc>
-              <a:spcBef>
-                <a:spcPts val="55"/>
-              </a:spcBef>
-            </a:pPr>
-            <a:fld id="{81D60167-4931-47E6-BA6A-407CBD079E47}" type="slidenum">
-              <a:rPr dirty="0"/>
-              <a:t>2</a:t>
-            </a:fld>
-            <a:r>
-              <a:rPr spc="-15" dirty="0"/>
-              <a:t> </a:t>
-            </a:r>
-            <a:r>
-              <a:rPr dirty="0"/>
-              <a:t>/</a:t>
-            </a:r>
-            <a:r>
-              <a:rPr spc="5" dirty="0"/>
-              <a:t> </a:t>
-            </a:r>
-            <a:r>
-              <a:rPr spc="-25" dirty="0"/>
-              <a:t>14</a:t>
-            </a:r>
           </a:p>
         </p:txBody>
       </p:sp>
@@ -12349,6 +12897,10 @@
           </p:nvPr>
         </p:nvSpPr>
         <p:spPr>
+          <a:xfrm>
+            <a:off x="11275097" y="6507344"/>
+            <a:ext cx="351790" cy="145553"/>
+          </a:xfrm>
           <a:prstGeom prst="rect">
             <a:avLst/>
           </a:prstGeom>
@@ -12384,9 +12936,10 @@
               <a:t> </a:t>
             </a:r>
             <a:r>
-              <a:rPr spc="-25" dirty="0"/>
-              <a:t>14</a:t>
-            </a:r>
+              <a:rPr lang="pt-BR" spc="-25" dirty="0"/>
+              <a:t>18</a:t>
+            </a:r>
+            <a:endParaRPr spc="-25" dirty="0"/>
           </a:p>
         </p:txBody>
       </p:sp>
@@ -14103,6 +14656,10 @@
           </p:nvPr>
         </p:nvSpPr>
         <p:spPr>
+          <a:xfrm>
+            <a:off x="11275097" y="6507344"/>
+            <a:ext cx="351790" cy="145553"/>
+          </a:xfrm>
           <a:prstGeom prst="rect">
             <a:avLst/>
           </a:prstGeom>
@@ -14138,9 +14695,10 @@
               <a:t> </a:t>
             </a:r>
             <a:r>
-              <a:rPr spc="-25" dirty="0"/>
-              <a:t>14</a:t>
-            </a:r>
+              <a:rPr lang="pt-BR" spc="-25" dirty="0"/>
+              <a:t>18</a:t>
+            </a:r>
+            <a:endParaRPr spc="-25" dirty="0"/>
           </a:p>
         </p:txBody>
       </p:sp>
@@ -15423,7 +15981,7 @@
                 <a:latin typeface="Calibri"/>
                 <a:cs typeface="Calibri"/>
               </a:rPr>
-              <a:t>3 Extras</a:t>
+              <a:t>4 Extras</a:t>
             </a:r>
             <a:endParaRPr sz="1300" dirty="0">
               <a:latin typeface="Calibri"/>
@@ -16340,6 +16898,10 @@
           </p:nvPr>
         </p:nvSpPr>
         <p:spPr>
+          <a:xfrm>
+            <a:off x="11275097" y="6507344"/>
+            <a:ext cx="351790" cy="145553"/>
+          </a:xfrm>
           <a:prstGeom prst="rect">
             <a:avLst/>
           </a:prstGeom>
@@ -16375,9 +16937,10 @@
               <a:t> </a:t>
             </a:r>
             <a:r>
-              <a:rPr spc="-25" dirty="0"/>
-              <a:t>14</a:t>
-            </a:r>
+              <a:rPr lang="pt-BR" spc="-25" dirty="0"/>
+              <a:t>18</a:t>
+            </a:r>
+            <a:endParaRPr spc="-25" dirty="0"/>
           </a:p>
         </p:txBody>
       </p:sp>
@@ -16455,8 +17018,8 @@
         </p:nvSpPr>
         <p:spPr>
           <a:xfrm>
-            <a:off x="534136" y="5076827"/>
-            <a:ext cx="5412740" cy="643766"/>
+            <a:off x="534135" y="5076827"/>
+            <a:ext cx="5689517" cy="643766"/>
           </a:xfrm>
           <a:prstGeom prst="rect">
             <a:avLst/>
@@ -16704,7 +17267,27 @@
                 <a:latin typeface="Calibri"/>
                 <a:cs typeface="Calibri"/>
               </a:rPr>
-              <a:t>() e </a:t>
+              <a:t>(), </a:t>
+            </a:r>
+            <a:r>
+              <a:rPr lang="pt-BR" sz="1200" dirty="0" err="1">
+                <a:solidFill>
+                  <a:srgbClr val="191919"/>
+                </a:solidFill>
+                <a:latin typeface="Calibri"/>
+                <a:cs typeface="Calibri"/>
+              </a:rPr>
+              <a:t>amostrar_valor</a:t>
+            </a:r>
+            <a:r>
+              <a:rPr lang="pt-BR" sz="1200" dirty="0">
+                <a:solidFill>
+                  <a:srgbClr val="191919"/>
+                </a:solidFill>
+                <a:latin typeface="Calibri"/>
+                <a:cs typeface="Calibri"/>
+              </a:rPr>
+              <a:t> e </a:t>
             </a:r>
             <a:r>
               <a:rPr lang="pt-BR" sz="1200" dirty="0" err="1">
@@ -19771,6 +20354,10 @@
           </p:nvPr>
         </p:nvSpPr>
         <p:spPr>
+          <a:xfrm>
+            <a:off x="11275097" y="6507344"/>
+            <a:ext cx="351790" cy="145553"/>
+          </a:xfrm>
           <a:prstGeom prst="rect">
             <a:avLst/>
           </a:prstGeom>
@@ -19806,9 +20393,10 @@
               <a:t> </a:t>
             </a:r>
             <a:r>
-              <a:rPr spc="-25" dirty="0"/>
-              <a:t>14</a:t>
-            </a:r>
+              <a:rPr lang="pt-BR" spc="-25" dirty="0"/>
+              <a:t>18</a:t>
+            </a:r>
+            <a:endParaRPr spc="-25" dirty="0"/>
           </a:p>
         </p:txBody>
       </p:sp>
@@ -22573,6 +23161,10 @@
           </p:nvPr>
         </p:nvSpPr>
         <p:spPr>
+          <a:xfrm>
+            <a:off x="11275097" y="6507344"/>
+            <a:ext cx="351790" cy="145553"/>
+          </a:xfrm>
           <a:prstGeom prst="rect">
             <a:avLst/>
           </a:prstGeom>
@@ -22608,9 +23200,10 @@
               <a:t> </a:t>
             </a:r>
             <a:r>
-              <a:rPr spc="-25" dirty="0"/>
-              <a:t>14</a:t>
-            </a:r>
+              <a:rPr lang="pt-BR" spc="-25" dirty="0"/>
+              <a:t>18</a:t>
+            </a:r>
+            <a:endParaRPr spc="-25" dirty="0"/>
           </a:p>
         </p:txBody>
       </p:sp>

</xml_diff>